<commit_message>
Update the end-user manual for the changes since v51
Four releases landed after the deck was written and parts of it were
stale. Export Detailed no longer writes a sheet per resource type, so
that slide described a document the app stopped producing.

Adds a slide for consolidating the crew -- max pax, summed days -- with
the worked example and the warning that the total rises. That is the
step people forget and the one that changes the price, so it earns its
own page rather than a footnote.

Also: the Manpower slide covers the Scope Task column, the resources
slide covers Combine, the SOW Breakdown slide covers shared rows, and
the quick reference gains the consolidation rule.

Footers are numbered from a counter now, so inserting a slide cannot
leave the rest mislabelled. Bullet blocks are top-aligned; pptxgenjs
centres them vertically by default, which floated short lists in the
middle of tall cards.

Co-Authored-By: Claude Opus 5 <noreply@anthropic.com>
</commit_message>
<xml_diff>
--- a/docs/SHIC-Cost-Estimator-User-Manual.pptx
+++ b/docs/SHIC-Cost-Estimator-User-Manual.pptx
@@ -25,9 +25,10 @@
     <p:sldId id="273" r:id="rId19"/>
     <p:sldId id="274" r:id="rId20"/>
     <p:sldId id="275" r:id="rId21"/>
+    <p:sldId id="276" r:id="rId22"/>
   </p:sldIdLst>
   <p:notesMasterIdLst>
-    <p:notesMasterId r:id="rId22"/>
+    <p:notesMasterId r:id="rId23"/>
   </p:notesMasterIdLst>
   <p:sldSz cx="12192000" cy="6858000"/>
   <p:notesSz cx="6858000" cy="12192000"/>
@@ -609,7 +610,7 @@
           <a:p>
             <a:r>
               <a:rPr lang="en-US" dirty="0"/>
-              <a:t>The Days column exists on Tools only — equipment is often hired by the day. Materials and PPE are one-off purchases.</a:t>
+              <a:t>This is the step people forget, and it is the one that changes the price. Consolidate before you generate the CE. The uplift is not an error — it is the cost of having the crew on site for the whole job.</a:t>
             </a:r>
             <a:endParaRPr lang="en-US" dirty="0"/>
           </a:p>
@@ -697,7 +698,7 @@
           <a:p>
             <a:r>
               <a:rPr lang="en-US" dirty="0"/>
-              <a:t>The category headings change slightly by CE type — Supply jobs use Allowance instead of Accommodation.</a:t>
+              <a:t>The Days column exists on Tools only — equipment is often hired by the day. Materials and PPE are one-off purchases.</a:t>
             </a:r>
             <a:endParaRPr lang="en-US" dirty="0"/>
           </a:p>
@@ -785,7 +786,7 @@
           <a:p>
             <a:r>
               <a:rPr lang="en-US" dirty="0"/>
-              <a:t>The margin is saved with the CE. Until recently it was silently discarded on save — if you reopen an old CE and the selling price line is missing, that is why.</a:t>
+              <a:t>The category headings change slightly by CE type — Supply jobs use Allowance instead of Accommodation.</a:t>
             </a:r>
             <a:endParaRPr lang="en-US" dirty="0"/>
           </a:p>
@@ -873,7 +874,7 @@
           <a:p>
             <a:r>
               <a:rPr lang="en-US" dirty="0"/>
-              <a:t>Make clear that Check CE is advisory, not a lock. The only hard blocks are the four listed at the bottom.</a:t>
+              <a:t>The margin is saved with the CE. Until recently it was silently discarded on save — if you reopen an old CE and the selling price line is missing, that is why.</a:t>
             </a:r>
             <a:endParaRPr lang="en-US" dirty="0"/>
           </a:p>
@@ -961,7 +962,7 @@
           <a:p>
             <a:r>
               <a:rPr lang="en-US" dirty="0"/>
-              <a:t>Draft vs Save is the distinction people get wrong. A draft is private and unfinished; a saved CE is the record the team sees.</a:t>
+              <a:t>Make clear that Check CE is advisory, not a lock. The only hard blocks are the four listed at the bottom.</a:t>
             </a:r>
             <a:endParaRPr lang="en-US" dirty="0"/>
           </a:p>
@@ -1049,7 +1050,7 @@
           <a:p>
             <a:r>
               <a:rPr lang="en-US" dirty="0"/>
-              <a:t>Generate CE is the deliverable. Everything before it exists to make this page right.</a:t>
+              <a:t>Draft vs Save is the distinction people get wrong. A draft is private and unfinished; a saved CE is the record the team sees.</a:t>
             </a:r>
             <a:endParaRPr lang="en-US" dirty="0"/>
           </a:p>
@@ -1137,7 +1138,7 @@
           <a:p>
             <a:r>
               <a:rPr lang="en-US" dirty="0"/>
-              <a:t>Monitoring is the register the whole team reads. Keeping status and remarks current is what makes it worth having.</a:t>
+              <a:t>Generate CE is the deliverable. Everything before it exists to make this page right.</a:t>
             </a:r>
             <a:endParaRPr lang="en-US" dirty="0"/>
           </a:p>
@@ -1225,7 +1226,7 @@
           <a:p>
             <a:r>
               <a:rPr lang="en-US" dirty="0"/>
-              <a:t>Reassure people. The most common support call is someone who saved offline and thinks their work is gone.</a:t>
+              <a:t>Monitoring is the register the whole team reads. Keeping status and remarks current is what makes it worth having.</a:t>
             </a:r>
             <a:endParaRPr lang="en-US" dirty="0"/>
           </a:p>
@@ -1313,7 +1314,7 @@
           <a:p>
             <a:r>
               <a:rPr lang="en-US" dirty="0"/>
-              <a:t>The middle one matters most: a permission refusal is not a session problem, and signing in again just wastes time.</a:t>
+              <a:t>Reassure people. The most common support call is someone who saved offline and thinks their work is gone.</a:t>
             </a:r>
             <a:endParaRPr lang="en-US" dirty="0"/>
           </a:p>
@@ -1401,7 +1402,7 @@
           <a:p>
             <a:r>
               <a:rPr lang="en-US" dirty="0"/>
-              <a:t>Whoever maintains rates should own the Masterlist. Estimators should be picking from it, not typing over it.</a:t>
+              <a:t>The middle one matters most: a permission refusal is not a session problem, and signing in again just wastes time.</a:t>
             </a:r>
             <a:endParaRPr lang="en-US" dirty="0"/>
           </a:p>
@@ -1577,7 +1578,7 @@
           <a:p>
             <a:r>
               <a:rPr lang="en-US" dirty="0"/>
-              <a:t>Close by pointing people at Check CE. It answers most "why is this number wrong" questions without a support call.</a:t>
+              <a:t>Whoever maintains rates should own the Masterlist. Estimators should be picking from it, not typing over it.</a:t>
             </a:r>
             <a:endParaRPr lang="en-US" dirty="0"/>
           </a:p>
@@ -1601,6 +1602,94 @@
             <a:fld id="{F7021451-1387-4CA6-816F-3879F97B5CBC}" type="slidenum">
               <a:rPr lang="en-US"/>
               <a:t>20</a:t>
+            </a:fld>
+            <a:endParaRPr lang="en-US"/>
+          </a:p>
+        </p:txBody>
+      </p:sp>
+    </p:spTree>
+    <p:extLst>
+      <p:ext uri="{BB962C8B-B14F-4D97-AF65-F5344CB8AC3E}">
+        <p14:creationId xmlns:p14="http://schemas.microsoft.com/office/powerpoint/2010/main" val="1024086991"/>
+      </p:ext>
+    </p:extLst>
+  </p:cSld>
+  <p:clrMapOvr>
+    <a:masterClrMapping/>
+  </p:clrMapOvr>
+</p:notes>
+</file>
+
+<file path=ppt/notesSlides/notesSlide21.xml><?xml version="1.0" encoding="utf-8"?>
+<p:notes xmlns:a="http://schemas.openxmlformats.org/drawingml/2006/main" xmlns:r="http://schemas.openxmlformats.org/officeDocument/2006/relationships" xmlns:p="http://schemas.openxmlformats.org/presentationml/2006/main">
+  <p:cSld>
+    <p:spTree>
+      <p:nvGrpSpPr>
+        <p:cNvPr id="1" name=""/>
+        <p:cNvGrpSpPr/>
+        <p:nvPr/>
+      </p:nvGrpSpPr>
+      <p:grpSpPr>
+        <a:xfrm>
+          <a:off x="0" y="0"/>
+          <a:ext cx="0" cy="0"/>
+          <a:chOff x="0" y="0"/>
+          <a:chExt cx="0" cy="0"/>
+        </a:xfrm>
+      </p:grpSpPr>
+      <p:sp>
+        <p:nvSpPr>
+          <p:cNvPr id="2" name="Slide Image Placeholder 1"/>
+          <p:cNvSpPr>
+            <a:spLocks noGrp="1" noRot="1" noChangeAspect="1"/>
+          </p:cNvSpPr>
+          <p:nvPr>
+            <p:ph type="sldImg"/>
+          </p:nvPr>
+        </p:nvSpPr>
+        <p:spPr/>
+      </p:sp>
+      <p:sp>
+        <p:nvSpPr>
+          <p:cNvPr id="3" name="Notes Placeholder 2"/>
+          <p:cNvSpPr>
+            <a:spLocks noGrp="1"/>
+          </p:cNvSpPr>
+          <p:nvPr>
+            <p:ph type="body" idx="1"/>
+          </p:nvPr>
+        </p:nvSpPr>
+        <p:spPr/>
+        <p:txBody>
+          <a:bodyPr/>
+          <a:lstStyle/>
+          <a:p>
+            <a:r>
+              <a:rPr lang="en-US" dirty="0"/>
+              <a:t>Close by pointing people at Check CE. It answers most "why is this number wrong" questions without a support call.</a:t>
+            </a:r>
+            <a:endParaRPr lang="en-US" dirty="0"/>
+          </a:p>
+        </p:txBody>
+      </p:sp>
+      <p:sp>
+        <p:nvSpPr>
+          <p:cNvPr id="4" name="Slide Number Placeholder 3"/>
+          <p:cNvSpPr>
+            <a:spLocks noGrp="1"/>
+          </p:cNvSpPr>
+          <p:nvPr>
+            <p:ph type="sldNum" sz="quarter" idx="10"/>
+          </p:nvPr>
+        </p:nvSpPr>
+        <p:spPr/>
+        <p:txBody>
+          <a:bodyPr/>
+          <a:lstStyle/>
+          <a:p>
+            <a:fld id="{F7021451-1387-4CA6-816F-3879F97B5CBC}" type="slidenum">
+              <a:rPr lang="en-US"/>
+              <a:t>21</a:t>
             </a:fld>
             <a:endParaRPr lang="en-US"/>
           </a:p>
@@ -3124,6 +3213,1773 @@
                 <a:ea typeface="Arial" pitchFamily="34" charset="-122"/>
                 <a:cs typeface="Arial" pitchFamily="34" charset="-120"/>
               </a:rPr>
+              <a:t>STEP 4 · CONSOLIDATE</a:t>
+            </a:r>
+            <a:endParaRPr lang="en-US" sz="1100" dirty="0"/>
+          </a:p>
+        </p:txBody>
+      </p:sp>
+      <p:sp>
+        <p:nvSpPr>
+          <p:cNvPr id="3" name="Text 1"/>
+          <p:cNvSpPr/>
+          <p:nvPr/>
+        </p:nvSpPr>
+        <p:spPr>
+          <a:xfrm>
+            <a:off x="566928" y="694944"/>
+            <a:ext cx="11055096" cy="566928"/>
+          </a:xfrm>
+          <a:prstGeom prst="rect">
+            <a:avLst/>
+          </a:prstGeom>
+          <a:noFill/>
+          <a:ln/>
+        </p:spPr>
+        <p:txBody>
+          <a:bodyPr wrap="square" lIns="0" tIns="0" rIns="0" bIns="0" rtlCol="0" anchor="ctr"/>
+          <a:lstStyle/>
+          <a:p>
+            <a:pPr indent="0" marL="0">
+              <a:buNone/>
+            </a:pPr>
+            <a:r>
+              <a:rPr lang="en-US" sz="3200" b="1" dirty="0">
+                <a:solidFill>
+                  <a:srgbClr val="E6EDF3"/>
+                </a:solidFill>
+                <a:latin typeface="Arial" pitchFamily="34" charset="0"/>
+                <a:ea typeface="Arial" pitchFamily="34" charset="-122"/>
+                <a:cs typeface="Arial" pitchFamily="34" charset="-120"/>
+              </a:rPr>
+              <a:t>One crew, several tasks</a:t>
+            </a:r>
+            <a:endParaRPr lang="en-US" sz="3200" dirty="0"/>
+          </a:p>
+        </p:txBody>
+      </p:sp>
+      <p:sp>
+        <p:nvSpPr>
+          <p:cNvPr id="4" name="Text 2"/>
+          <p:cNvSpPr/>
+          <p:nvPr/>
+        </p:nvSpPr>
+        <p:spPr>
+          <a:xfrm>
+            <a:off x="566928" y="1298448"/>
+            <a:ext cx="10972800" cy="365760"/>
+          </a:xfrm>
+          <a:prstGeom prst="rect">
+            <a:avLst/>
+          </a:prstGeom>
+          <a:noFill/>
+          <a:ln/>
+        </p:spPr>
+        <p:txBody>
+          <a:bodyPr wrap="square" lIns="0" tIns="0" rIns="0" bIns="0" rtlCol="0" anchor="t"/>
+          <a:lstStyle/>
+          <a:p>
+            <a:pPr algn="l" indent="0" marL="0">
+              <a:lnSpc>
+                <a:spcPts val="2000"/>
+              </a:lnSpc>
+              <a:buNone/>
+            </a:pPr>
+            <a:r>
+              <a:rPr lang="en-US" sz="1400" dirty="0">
+                <a:solidFill>
+                  <a:srgbClr val="9AA4AF"/>
+                </a:solidFill>
+                <a:latin typeface="Calibri" pitchFamily="34" charset="0"/>
+                <a:ea typeface="Calibri" pitchFamily="34" charset="-122"/>
+                <a:cs typeface="Calibri" pitchFamily="34" charset="-120"/>
+              </a:rPr>
+              <a:t>The same electrician appears under every task that needs one. Combine them into the crew you actually mobilise.</a:t>
+            </a:r>
+            <a:endParaRPr lang="en-US" sz="1400" dirty="0"/>
+          </a:p>
+        </p:txBody>
+      </p:sp>
+      <p:sp>
+        <p:nvSpPr>
+          <p:cNvPr id="5" name="Text 3"/>
+          <p:cNvSpPr/>
+          <p:nvPr/>
+        </p:nvSpPr>
+        <p:spPr>
+          <a:xfrm>
+            <a:off x="566928" y="1911096"/>
+            <a:ext cx="2743200" cy="256032"/>
+          </a:xfrm>
+          <a:prstGeom prst="rect">
+            <a:avLst/>
+          </a:prstGeom>
+          <a:noFill/>
+          <a:ln/>
+        </p:spPr>
+        <p:txBody>
+          <a:bodyPr wrap="square" lIns="0" tIns="0" rIns="0" bIns="0" rtlCol="0" anchor="ctr"/>
+          <a:lstStyle/>
+          <a:p>
+            <a:pPr algn="l" indent="0" marL="0">
+              <a:buNone/>
+            </a:pPr>
+            <a:endParaRPr lang="en-US" sz="850" dirty="0"/>
+          </a:p>
+        </p:txBody>
+      </p:sp>
+      <p:sp>
+        <p:nvSpPr>
+          <p:cNvPr id="6" name="Text 4"/>
+          <p:cNvSpPr/>
+          <p:nvPr/>
+        </p:nvSpPr>
+        <p:spPr>
+          <a:xfrm>
+            <a:off x="3310128" y="1911096"/>
+            <a:ext cx="1143000" cy="256032"/>
+          </a:xfrm>
+          <a:prstGeom prst="rect">
+            <a:avLst/>
+          </a:prstGeom>
+          <a:noFill/>
+          <a:ln/>
+        </p:spPr>
+        <p:txBody>
+          <a:bodyPr wrap="square" lIns="0" tIns="0" rIns="0" bIns="0" rtlCol="0" anchor="ctr"/>
+          <a:lstStyle/>
+          <a:p>
+            <a:pPr algn="ctr" indent="0" marL="0">
+              <a:buNone/>
+            </a:pPr>
+            <a:r>
+              <a:rPr lang="en-US" sz="850" b="1" spc="100" kern="0" dirty="0">
+                <a:solidFill>
+                  <a:srgbClr val="9AA4AF"/>
+                </a:solidFill>
+                <a:latin typeface="Calibri" pitchFamily="34" charset="0"/>
+                <a:ea typeface="Calibri" pitchFamily="34" charset="-122"/>
+                <a:cs typeface="Calibri" pitchFamily="34" charset="-120"/>
+              </a:rPr>
+              <a:t>PAX</a:t>
+            </a:r>
+            <a:endParaRPr lang="en-US" sz="850" dirty="0"/>
+          </a:p>
+        </p:txBody>
+      </p:sp>
+      <p:sp>
+        <p:nvSpPr>
+          <p:cNvPr id="7" name="Text 5"/>
+          <p:cNvSpPr/>
+          <p:nvPr/>
+        </p:nvSpPr>
+        <p:spPr>
+          <a:xfrm>
+            <a:off x="4453128" y="1911096"/>
+            <a:ext cx="1143000" cy="256032"/>
+          </a:xfrm>
+          <a:prstGeom prst="rect">
+            <a:avLst/>
+          </a:prstGeom>
+          <a:noFill/>
+          <a:ln/>
+        </p:spPr>
+        <p:txBody>
+          <a:bodyPr wrap="square" lIns="0" tIns="0" rIns="0" bIns="0" rtlCol="0" anchor="ctr"/>
+          <a:lstStyle/>
+          <a:p>
+            <a:pPr algn="ctr" indent="0" marL="0">
+              <a:buNone/>
+            </a:pPr>
+            <a:r>
+              <a:rPr lang="en-US" sz="850" b="1" spc="100" kern="0" dirty="0">
+                <a:solidFill>
+                  <a:srgbClr val="9AA4AF"/>
+                </a:solidFill>
+                <a:latin typeface="Calibri" pitchFamily="34" charset="0"/>
+                <a:ea typeface="Calibri" pitchFamily="34" charset="-122"/>
+                <a:cs typeface="Calibri" pitchFamily="34" charset="-120"/>
+              </a:rPr>
+              <a:t>DAYS</a:t>
+            </a:r>
+            <a:endParaRPr lang="en-US" sz="850" dirty="0"/>
+          </a:p>
+        </p:txBody>
+      </p:sp>
+      <p:sp>
+        <p:nvSpPr>
+          <p:cNvPr id="8" name="Text 6"/>
+          <p:cNvSpPr/>
+          <p:nvPr/>
+        </p:nvSpPr>
+        <p:spPr>
+          <a:xfrm>
+            <a:off x="5596128" y="1911096"/>
+            <a:ext cx="1828800" cy="256032"/>
+          </a:xfrm>
+          <a:prstGeom prst="rect">
+            <a:avLst/>
+          </a:prstGeom>
+          <a:noFill/>
+          <a:ln/>
+        </p:spPr>
+        <p:txBody>
+          <a:bodyPr wrap="square" lIns="0" tIns="0" rIns="0" bIns="0" rtlCol="0" anchor="ctr"/>
+          <a:lstStyle/>
+          <a:p>
+            <a:pPr algn="r" indent="0" marL="0">
+              <a:buNone/>
+            </a:pPr>
+            <a:r>
+              <a:rPr lang="en-US" sz="850" b="1" spc="100" kern="0" dirty="0">
+                <a:solidFill>
+                  <a:srgbClr val="9AA4AF"/>
+                </a:solidFill>
+                <a:latin typeface="Calibri" pitchFamily="34" charset="0"/>
+                <a:ea typeface="Calibri" pitchFamily="34" charset="-122"/>
+                <a:cs typeface="Calibri" pitchFamily="34" charset="-120"/>
+              </a:rPr>
+              <a:t>COST</a:t>
+            </a:r>
+            <a:endParaRPr lang="en-US" sz="850" dirty="0"/>
+          </a:p>
+        </p:txBody>
+      </p:sp>
+      <p:sp>
+        <p:nvSpPr>
+          <p:cNvPr id="9" name="Shape 7"/>
+          <p:cNvSpPr/>
+          <p:nvPr/>
+        </p:nvSpPr>
+        <p:spPr>
+          <a:xfrm>
+            <a:off x="566928" y="2185416"/>
+            <a:ext cx="6858000" cy="347472"/>
+          </a:xfrm>
+          <a:prstGeom prst="rect">
+            <a:avLst/>
+          </a:prstGeom>
+          <a:solidFill>
+            <a:srgbClr val="1C2128"/>
+          </a:solidFill>
+          <a:ln w="6350">
+            <a:solidFill>
+              <a:srgbClr val="30363D"/>
+            </a:solidFill>
+            <a:prstDash val="solid"/>
+          </a:ln>
+        </p:spPr>
+      </p:sp>
+      <p:sp>
+        <p:nvSpPr>
+          <p:cNvPr id="10" name="Text 8"/>
+          <p:cNvSpPr/>
+          <p:nvPr/>
+        </p:nvSpPr>
+        <p:spPr>
+          <a:xfrm>
+            <a:off x="621792" y="2185416"/>
+            <a:ext cx="2633472" cy="347472"/>
+          </a:xfrm>
+          <a:prstGeom prst="rect">
+            <a:avLst/>
+          </a:prstGeom>
+          <a:noFill/>
+          <a:ln/>
+        </p:spPr>
+        <p:txBody>
+          <a:bodyPr wrap="square" lIns="0" tIns="0" rIns="0" bIns="0" rtlCol="0" anchor="ctr"/>
+          <a:lstStyle/>
+          <a:p>
+            <a:pPr algn="l" indent="0" marL="0">
+              <a:buNone/>
+            </a:pPr>
+            <a:r>
+              <a:rPr lang="en-US" sz="1050" dirty="0">
+                <a:solidFill>
+                  <a:srgbClr val="E6EDF3"/>
+                </a:solidFill>
+                <a:latin typeface="Calibri" pitchFamily="34" charset="0"/>
+                <a:ea typeface="Calibri" pitchFamily="34" charset="-122"/>
+                <a:cs typeface="Calibri" pitchFamily="34" charset="-120"/>
+              </a:rPr>
+              <a:t>Task 1  Cut and prep</a:t>
+            </a:r>
+            <a:endParaRPr lang="en-US" sz="1050" dirty="0"/>
+          </a:p>
+        </p:txBody>
+      </p:sp>
+      <p:sp>
+        <p:nvSpPr>
+          <p:cNvPr id="11" name="Text 9"/>
+          <p:cNvSpPr/>
+          <p:nvPr/>
+        </p:nvSpPr>
+        <p:spPr>
+          <a:xfrm>
+            <a:off x="3364992" y="2185416"/>
+            <a:ext cx="1033272" cy="347472"/>
+          </a:xfrm>
+          <a:prstGeom prst="rect">
+            <a:avLst/>
+          </a:prstGeom>
+          <a:noFill/>
+          <a:ln/>
+        </p:spPr>
+        <p:txBody>
+          <a:bodyPr wrap="square" lIns="0" tIns="0" rIns="0" bIns="0" rtlCol="0" anchor="ctr"/>
+          <a:lstStyle/>
+          <a:p>
+            <a:pPr algn="ctr" indent="0" marL="0">
+              <a:buNone/>
+            </a:pPr>
+            <a:r>
+              <a:rPr lang="en-US" sz="1050" dirty="0">
+                <a:solidFill>
+                  <a:srgbClr val="E6EDF3"/>
+                </a:solidFill>
+                <a:latin typeface="Calibri" pitchFamily="34" charset="0"/>
+                <a:ea typeface="Calibri" pitchFamily="34" charset="-122"/>
+                <a:cs typeface="Calibri" pitchFamily="34" charset="-120"/>
+              </a:rPr>
+              <a:t>1</a:t>
+            </a:r>
+            <a:endParaRPr lang="en-US" sz="1050" dirty="0"/>
+          </a:p>
+        </p:txBody>
+      </p:sp>
+      <p:sp>
+        <p:nvSpPr>
+          <p:cNvPr id="12" name="Text 10"/>
+          <p:cNvSpPr/>
+          <p:nvPr/>
+        </p:nvSpPr>
+        <p:spPr>
+          <a:xfrm>
+            <a:off x="4507992" y="2185416"/>
+            <a:ext cx="1033272" cy="347472"/>
+          </a:xfrm>
+          <a:prstGeom prst="rect">
+            <a:avLst/>
+          </a:prstGeom>
+          <a:noFill/>
+          <a:ln/>
+        </p:spPr>
+        <p:txBody>
+          <a:bodyPr wrap="square" lIns="0" tIns="0" rIns="0" bIns="0" rtlCol="0" anchor="ctr"/>
+          <a:lstStyle/>
+          <a:p>
+            <a:pPr algn="ctr" indent="0" marL="0">
+              <a:buNone/>
+            </a:pPr>
+            <a:r>
+              <a:rPr lang="en-US" sz="1050" dirty="0">
+                <a:solidFill>
+                  <a:srgbClr val="E6EDF3"/>
+                </a:solidFill>
+                <a:latin typeface="Calibri" pitchFamily="34" charset="0"/>
+                <a:ea typeface="Calibri" pitchFamily="34" charset="-122"/>
+                <a:cs typeface="Calibri" pitchFamily="34" charset="-120"/>
+              </a:rPr>
+              <a:t>2</a:t>
+            </a:r>
+            <a:endParaRPr lang="en-US" sz="1050" dirty="0"/>
+          </a:p>
+        </p:txBody>
+      </p:sp>
+      <p:sp>
+        <p:nvSpPr>
+          <p:cNvPr id="13" name="Text 11"/>
+          <p:cNvSpPr/>
+          <p:nvPr/>
+        </p:nvSpPr>
+        <p:spPr>
+          <a:xfrm>
+            <a:off x="5650992" y="2185416"/>
+            <a:ext cx="1719072" cy="347472"/>
+          </a:xfrm>
+          <a:prstGeom prst="rect">
+            <a:avLst/>
+          </a:prstGeom>
+          <a:noFill/>
+          <a:ln/>
+        </p:spPr>
+        <p:txBody>
+          <a:bodyPr wrap="square" lIns="0" tIns="0" rIns="0" bIns="0" rtlCol="0" anchor="ctr"/>
+          <a:lstStyle/>
+          <a:p>
+            <a:pPr algn="r" indent="0" marL="0">
+              <a:buNone/>
+            </a:pPr>
+            <a:r>
+              <a:rPr lang="en-US" sz="1050" dirty="0">
+                <a:solidFill>
+                  <a:srgbClr val="E6EDF3"/>
+                </a:solidFill>
+                <a:latin typeface="Calibri" pitchFamily="34" charset="0"/>
+                <a:ea typeface="Calibri" pitchFamily="34" charset="-122"/>
+                <a:cs typeface="Calibri" pitchFamily="34" charset="-120"/>
+              </a:rPr>
+              <a:t>₱1,700</a:t>
+            </a:r>
+            <a:endParaRPr lang="en-US" sz="1050" dirty="0"/>
+          </a:p>
+        </p:txBody>
+      </p:sp>
+      <p:sp>
+        <p:nvSpPr>
+          <p:cNvPr id="14" name="Shape 12"/>
+          <p:cNvSpPr/>
+          <p:nvPr/>
+        </p:nvSpPr>
+        <p:spPr>
+          <a:xfrm>
+            <a:off x="566928" y="2532888"/>
+            <a:ext cx="6858000" cy="347472"/>
+          </a:xfrm>
+          <a:prstGeom prst="rect">
+            <a:avLst/>
+          </a:prstGeom>
+          <a:solidFill>
+            <a:srgbClr val="161B22"/>
+          </a:solidFill>
+          <a:ln w="6350">
+            <a:solidFill>
+              <a:srgbClr val="30363D"/>
+            </a:solidFill>
+            <a:prstDash val="solid"/>
+          </a:ln>
+        </p:spPr>
+      </p:sp>
+      <p:sp>
+        <p:nvSpPr>
+          <p:cNvPr id="15" name="Text 13"/>
+          <p:cNvSpPr/>
+          <p:nvPr/>
+        </p:nvSpPr>
+        <p:spPr>
+          <a:xfrm>
+            <a:off x="621792" y="2532888"/>
+            <a:ext cx="2633472" cy="347472"/>
+          </a:xfrm>
+          <a:prstGeom prst="rect">
+            <a:avLst/>
+          </a:prstGeom>
+          <a:noFill/>
+          <a:ln/>
+        </p:spPr>
+        <p:txBody>
+          <a:bodyPr wrap="square" lIns="0" tIns="0" rIns="0" bIns="0" rtlCol="0" anchor="ctr"/>
+          <a:lstStyle/>
+          <a:p>
+            <a:pPr algn="l" indent="0" marL="0">
+              <a:buNone/>
+            </a:pPr>
+            <a:r>
+              <a:rPr lang="en-US" sz="1050" dirty="0">
+                <a:solidFill>
+                  <a:srgbClr val="E6EDF3"/>
+                </a:solidFill>
+                <a:latin typeface="Calibri" pitchFamily="34" charset="0"/>
+                <a:ea typeface="Calibri" pitchFamily="34" charset="-122"/>
+                <a:cs typeface="Calibri" pitchFamily="34" charset="-120"/>
+              </a:rPr>
+              <a:t>Task 2  Final machining</a:t>
+            </a:r>
+            <a:endParaRPr lang="en-US" sz="1050" dirty="0"/>
+          </a:p>
+        </p:txBody>
+      </p:sp>
+      <p:sp>
+        <p:nvSpPr>
+          <p:cNvPr id="16" name="Text 14"/>
+          <p:cNvSpPr/>
+          <p:nvPr/>
+        </p:nvSpPr>
+        <p:spPr>
+          <a:xfrm>
+            <a:off x="3364992" y="2532888"/>
+            <a:ext cx="1033272" cy="347472"/>
+          </a:xfrm>
+          <a:prstGeom prst="rect">
+            <a:avLst/>
+          </a:prstGeom>
+          <a:noFill/>
+          <a:ln/>
+        </p:spPr>
+        <p:txBody>
+          <a:bodyPr wrap="square" lIns="0" tIns="0" rIns="0" bIns="0" rtlCol="0" anchor="ctr"/>
+          <a:lstStyle/>
+          <a:p>
+            <a:pPr algn="ctr" indent="0" marL="0">
+              <a:buNone/>
+            </a:pPr>
+            <a:r>
+              <a:rPr lang="en-US" sz="1050" dirty="0">
+                <a:solidFill>
+                  <a:srgbClr val="E6EDF3"/>
+                </a:solidFill>
+                <a:latin typeface="Calibri" pitchFamily="34" charset="0"/>
+                <a:ea typeface="Calibri" pitchFamily="34" charset="-122"/>
+                <a:cs typeface="Calibri" pitchFamily="34" charset="-120"/>
+              </a:rPr>
+              <a:t>3</a:t>
+            </a:r>
+            <a:endParaRPr lang="en-US" sz="1050" dirty="0"/>
+          </a:p>
+        </p:txBody>
+      </p:sp>
+      <p:sp>
+        <p:nvSpPr>
+          <p:cNvPr id="17" name="Text 15"/>
+          <p:cNvSpPr/>
+          <p:nvPr/>
+        </p:nvSpPr>
+        <p:spPr>
+          <a:xfrm>
+            <a:off x="4507992" y="2532888"/>
+            <a:ext cx="1033272" cy="347472"/>
+          </a:xfrm>
+          <a:prstGeom prst="rect">
+            <a:avLst/>
+          </a:prstGeom>
+          <a:noFill/>
+          <a:ln/>
+        </p:spPr>
+        <p:txBody>
+          <a:bodyPr wrap="square" lIns="0" tIns="0" rIns="0" bIns="0" rtlCol="0" anchor="ctr"/>
+          <a:lstStyle/>
+          <a:p>
+            <a:pPr algn="ctr" indent="0" marL="0">
+              <a:buNone/>
+            </a:pPr>
+            <a:r>
+              <a:rPr lang="en-US" sz="1050" dirty="0">
+                <a:solidFill>
+                  <a:srgbClr val="E6EDF3"/>
+                </a:solidFill>
+                <a:latin typeface="Calibri" pitchFamily="34" charset="0"/>
+                <a:ea typeface="Calibri" pitchFamily="34" charset="-122"/>
+                <a:cs typeface="Calibri" pitchFamily="34" charset="-120"/>
+              </a:rPr>
+              <a:t>5</a:t>
+            </a:r>
+            <a:endParaRPr lang="en-US" sz="1050" dirty="0"/>
+          </a:p>
+        </p:txBody>
+      </p:sp>
+      <p:sp>
+        <p:nvSpPr>
+          <p:cNvPr id="18" name="Text 16"/>
+          <p:cNvSpPr/>
+          <p:nvPr/>
+        </p:nvSpPr>
+        <p:spPr>
+          <a:xfrm>
+            <a:off x="5650992" y="2532888"/>
+            <a:ext cx="1719072" cy="347472"/>
+          </a:xfrm>
+          <a:prstGeom prst="rect">
+            <a:avLst/>
+          </a:prstGeom>
+          <a:noFill/>
+          <a:ln/>
+        </p:spPr>
+        <p:txBody>
+          <a:bodyPr wrap="square" lIns="0" tIns="0" rIns="0" bIns="0" rtlCol="0" anchor="ctr"/>
+          <a:lstStyle/>
+          <a:p>
+            <a:pPr algn="r" indent="0" marL="0">
+              <a:buNone/>
+            </a:pPr>
+            <a:r>
+              <a:rPr lang="en-US" sz="1050" dirty="0">
+                <a:solidFill>
+                  <a:srgbClr val="E6EDF3"/>
+                </a:solidFill>
+                <a:latin typeface="Calibri" pitchFamily="34" charset="0"/>
+                <a:ea typeface="Calibri" pitchFamily="34" charset="-122"/>
+                <a:cs typeface="Calibri" pitchFamily="34" charset="-120"/>
+              </a:rPr>
+              <a:t>₱12,750</a:t>
+            </a:r>
+            <a:endParaRPr lang="en-US" sz="1050" dirty="0"/>
+          </a:p>
+        </p:txBody>
+      </p:sp>
+      <p:sp>
+        <p:nvSpPr>
+          <p:cNvPr id="19" name="Shape 17"/>
+          <p:cNvSpPr/>
+          <p:nvPr/>
+        </p:nvSpPr>
+        <p:spPr>
+          <a:xfrm>
+            <a:off x="566928" y="2880360"/>
+            <a:ext cx="6858000" cy="347472"/>
+          </a:xfrm>
+          <a:prstGeom prst="rect">
+            <a:avLst/>
+          </a:prstGeom>
+          <a:solidFill>
+            <a:srgbClr val="1C2128"/>
+          </a:solidFill>
+          <a:ln w="6350">
+            <a:solidFill>
+              <a:srgbClr val="30363D"/>
+            </a:solidFill>
+            <a:prstDash val="solid"/>
+          </a:ln>
+        </p:spPr>
+      </p:sp>
+      <p:sp>
+        <p:nvSpPr>
+          <p:cNvPr id="20" name="Text 18"/>
+          <p:cNvSpPr/>
+          <p:nvPr/>
+        </p:nvSpPr>
+        <p:spPr>
+          <a:xfrm>
+            <a:off x="621792" y="2880360"/>
+            <a:ext cx="2633472" cy="347472"/>
+          </a:xfrm>
+          <a:prstGeom prst="rect">
+            <a:avLst/>
+          </a:prstGeom>
+          <a:noFill/>
+          <a:ln/>
+        </p:spPr>
+        <p:txBody>
+          <a:bodyPr wrap="square" lIns="0" tIns="0" rIns="0" bIns="0" rtlCol="0" anchor="ctr"/>
+          <a:lstStyle/>
+          <a:p>
+            <a:pPr algn="l" indent="0" marL="0">
+              <a:buNone/>
+            </a:pPr>
+            <a:r>
+              <a:rPr lang="en-US" sz="1050" dirty="0">
+                <a:solidFill>
+                  <a:srgbClr val="9AA4AF"/>
+                </a:solidFill>
+                <a:latin typeface="Calibri" pitchFamily="34" charset="0"/>
+                <a:ea typeface="Calibri" pitchFamily="34" charset="-122"/>
+                <a:cs typeface="Calibri" pitchFamily="34" charset="-120"/>
+              </a:rPr>
+              <a:t>Rows added up</a:t>
+            </a:r>
+            <a:endParaRPr lang="en-US" sz="1050" dirty="0"/>
+          </a:p>
+        </p:txBody>
+      </p:sp>
+      <p:sp>
+        <p:nvSpPr>
+          <p:cNvPr id="21" name="Text 19"/>
+          <p:cNvSpPr/>
+          <p:nvPr/>
+        </p:nvSpPr>
+        <p:spPr>
+          <a:xfrm>
+            <a:off x="3364992" y="2880360"/>
+            <a:ext cx="1033272" cy="347472"/>
+          </a:xfrm>
+          <a:prstGeom prst="rect">
+            <a:avLst/>
+          </a:prstGeom>
+          <a:noFill/>
+          <a:ln/>
+        </p:spPr>
+        <p:txBody>
+          <a:bodyPr wrap="square" lIns="0" tIns="0" rIns="0" bIns="0" rtlCol="0" anchor="ctr"/>
+          <a:lstStyle/>
+          <a:p>
+            <a:pPr algn="ctr" indent="0" marL="0">
+              <a:buNone/>
+            </a:pPr>
+            <a:endParaRPr lang="en-US" sz="1050" dirty="0"/>
+          </a:p>
+        </p:txBody>
+      </p:sp>
+      <p:sp>
+        <p:nvSpPr>
+          <p:cNvPr id="22" name="Text 20"/>
+          <p:cNvSpPr/>
+          <p:nvPr/>
+        </p:nvSpPr>
+        <p:spPr>
+          <a:xfrm>
+            <a:off x="4507992" y="2880360"/>
+            <a:ext cx="1033272" cy="347472"/>
+          </a:xfrm>
+          <a:prstGeom prst="rect">
+            <a:avLst/>
+          </a:prstGeom>
+          <a:noFill/>
+          <a:ln/>
+        </p:spPr>
+        <p:txBody>
+          <a:bodyPr wrap="square" lIns="0" tIns="0" rIns="0" bIns="0" rtlCol="0" anchor="ctr"/>
+          <a:lstStyle/>
+          <a:p>
+            <a:pPr algn="ctr" indent="0" marL="0">
+              <a:buNone/>
+            </a:pPr>
+            <a:endParaRPr lang="en-US" sz="1050" dirty="0"/>
+          </a:p>
+        </p:txBody>
+      </p:sp>
+      <p:sp>
+        <p:nvSpPr>
+          <p:cNvPr id="23" name="Text 21"/>
+          <p:cNvSpPr/>
+          <p:nvPr/>
+        </p:nvSpPr>
+        <p:spPr>
+          <a:xfrm>
+            <a:off x="5650992" y="2880360"/>
+            <a:ext cx="1719072" cy="347472"/>
+          </a:xfrm>
+          <a:prstGeom prst="rect">
+            <a:avLst/>
+          </a:prstGeom>
+          <a:noFill/>
+          <a:ln/>
+        </p:spPr>
+        <p:txBody>
+          <a:bodyPr wrap="square" lIns="0" tIns="0" rIns="0" bIns="0" rtlCol="0" anchor="ctr"/>
+          <a:lstStyle/>
+          <a:p>
+            <a:pPr algn="r" indent="0" marL="0">
+              <a:buNone/>
+            </a:pPr>
+            <a:r>
+              <a:rPr lang="en-US" sz="1050" dirty="0">
+                <a:solidFill>
+                  <a:srgbClr val="9AA4AF"/>
+                </a:solidFill>
+                <a:latin typeface="Calibri" pitchFamily="34" charset="0"/>
+                <a:ea typeface="Calibri" pitchFamily="34" charset="-122"/>
+                <a:cs typeface="Calibri" pitchFamily="34" charset="-120"/>
+              </a:rPr>
+              <a:t>₱14,450</a:t>
+            </a:r>
+            <a:endParaRPr lang="en-US" sz="1050" dirty="0"/>
+          </a:p>
+        </p:txBody>
+      </p:sp>
+      <p:sp>
+        <p:nvSpPr>
+          <p:cNvPr id="24" name="Shape 22"/>
+          <p:cNvSpPr/>
+          <p:nvPr/>
+        </p:nvSpPr>
+        <p:spPr>
+          <a:xfrm>
+            <a:off x="566928" y="3227832"/>
+            <a:ext cx="6858000" cy="347472"/>
+          </a:xfrm>
+          <a:prstGeom prst="rect">
+            <a:avLst/>
+          </a:prstGeom>
+          <a:solidFill>
+            <a:srgbClr val="161B22"/>
+          </a:solidFill>
+          <a:ln w="6350">
+            <a:solidFill>
+              <a:srgbClr val="30363D"/>
+            </a:solidFill>
+            <a:prstDash val="solid"/>
+          </a:ln>
+        </p:spPr>
+      </p:sp>
+      <p:sp>
+        <p:nvSpPr>
+          <p:cNvPr id="25" name="Text 23"/>
+          <p:cNvSpPr/>
+          <p:nvPr/>
+        </p:nvSpPr>
+        <p:spPr>
+          <a:xfrm>
+            <a:off x="621792" y="3227832"/>
+            <a:ext cx="2633472" cy="347472"/>
+          </a:xfrm>
+          <a:prstGeom prst="rect">
+            <a:avLst/>
+          </a:prstGeom>
+          <a:noFill/>
+          <a:ln/>
+        </p:spPr>
+        <p:txBody>
+          <a:bodyPr wrap="square" lIns="0" tIns="0" rIns="0" bIns="0" rtlCol="0" anchor="ctr"/>
+          <a:lstStyle/>
+          <a:p>
+            <a:pPr algn="l" indent="0" marL="0">
+              <a:buNone/>
+            </a:pPr>
+            <a:r>
+              <a:rPr lang="en-US" sz="1050" b="1" dirty="0">
+                <a:solidFill>
+                  <a:srgbClr val="F0A429"/>
+                </a:solidFill>
+                <a:latin typeface="Calibri" pitchFamily="34" charset="0"/>
+                <a:ea typeface="Calibri" pitchFamily="34" charset="-122"/>
+                <a:cs typeface="Calibri" pitchFamily="34" charset="-120"/>
+              </a:rPr>
+              <a:t>CONSOLIDATED CREW</a:t>
+            </a:r>
+            <a:endParaRPr lang="en-US" sz="1050" dirty="0"/>
+          </a:p>
+        </p:txBody>
+      </p:sp>
+      <p:sp>
+        <p:nvSpPr>
+          <p:cNvPr id="26" name="Text 24"/>
+          <p:cNvSpPr/>
+          <p:nvPr/>
+        </p:nvSpPr>
+        <p:spPr>
+          <a:xfrm>
+            <a:off x="3364992" y="3227832"/>
+            <a:ext cx="1033272" cy="347472"/>
+          </a:xfrm>
+          <a:prstGeom prst="rect">
+            <a:avLst/>
+          </a:prstGeom>
+          <a:noFill/>
+          <a:ln/>
+        </p:spPr>
+        <p:txBody>
+          <a:bodyPr wrap="square" lIns="0" tIns="0" rIns="0" bIns="0" rtlCol="0" anchor="ctr"/>
+          <a:lstStyle/>
+          <a:p>
+            <a:pPr algn="ctr" indent="0" marL="0">
+              <a:buNone/>
+            </a:pPr>
+            <a:r>
+              <a:rPr lang="en-US" sz="1050" b="1" dirty="0">
+                <a:solidFill>
+                  <a:srgbClr val="F0A429"/>
+                </a:solidFill>
+                <a:latin typeface="Calibri" pitchFamily="34" charset="0"/>
+                <a:ea typeface="Calibri" pitchFamily="34" charset="-122"/>
+                <a:cs typeface="Calibri" pitchFamily="34" charset="-120"/>
+              </a:rPr>
+              <a:t>3</a:t>
+            </a:r>
+            <a:endParaRPr lang="en-US" sz="1050" dirty="0"/>
+          </a:p>
+        </p:txBody>
+      </p:sp>
+      <p:sp>
+        <p:nvSpPr>
+          <p:cNvPr id="27" name="Text 25"/>
+          <p:cNvSpPr/>
+          <p:nvPr/>
+        </p:nvSpPr>
+        <p:spPr>
+          <a:xfrm>
+            <a:off x="4507992" y="3227832"/>
+            <a:ext cx="1033272" cy="347472"/>
+          </a:xfrm>
+          <a:prstGeom prst="rect">
+            <a:avLst/>
+          </a:prstGeom>
+          <a:noFill/>
+          <a:ln/>
+        </p:spPr>
+        <p:txBody>
+          <a:bodyPr wrap="square" lIns="0" tIns="0" rIns="0" bIns="0" rtlCol="0" anchor="ctr"/>
+          <a:lstStyle/>
+          <a:p>
+            <a:pPr algn="ctr" indent="0" marL="0">
+              <a:buNone/>
+            </a:pPr>
+            <a:r>
+              <a:rPr lang="en-US" sz="1050" b="1" dirty="0">
+                <a:solidFill>
+                  <a:srgbClr val="F0A429"/>
+                </a:solidFill>
+                <a:latin typeface="Calibri" pitchFamily="34" charset="0"/>
+                <a:ea typeface="Calibri" pitchFamily="34" charset="-122"/>
+                <a:cs typeface="Calibri" pitchFamily="34" charset="-120"/>
+              </a:rPr>
+              <a:t>7</a:t>
+            </a:r>
+            <a:endParaRPr lang="en-US" sz="1050" dirty="0"/>
+          </a:p>
+        </p:txBody>
+      </p:sp>
+      <p:sp>
+        <p:nvSpPr>
+          <p:cNvPr id="28" name="Text 26"/>
+          <p:cNvSpPr/>
+          <p:nvPr/>
+        </p:nvSpPr>
+        <p:spPr>
+          <a:xfrm>
+            <a:off x="5650992" y="3227832"/>
+            <a:ext cx="1719072" cy="347472"/>
+          </a:xfrm>
+          <a:prstGeom prst="rect">
+            <a:avLst/>
+          </a:prstGeom>
+          <a:noFill/>
+          <a:ln/>
+        </p:spPr>
+        <p:txBody>
+          <a:bodyPr wrap="square" lIns="0" tIns="0" rIns="0" bIns="0" rtlCol="0" anchor="ctr"/>
+          <a:lstStyle/>
+          <a:p>
+            <a:pPr algn="r" indent="0" marL="0">
+              <a:buNone/>
+            </a:pPr>
+            <a:r>
+              <a:rPr lang="en-US" sz="1050" b="1" dirty="0">
+                <a:solidFill>
+                  <a:srgbClr val="F0A429"/>
+                </a:solidFill>
+                <a:latin typeface="Calibri" pitchFamily="34" charset="0"/>
+                <a:ea typeface="Calibri" pitchFamily="34" charset="-122"/>
+                <a:cs typeface="Calibri" pitchFamily="34" charset="-120"/>
+              </a:rPr>
+              <a:t>₱17,850</a:t>
+            </a:r>
+            <a:endParaRPr lang="en-US" sz="1050" dirty="0"/>
+          </a:p>
+        </p:txBody>
+      </p:sp>
+      <p:sp>
+        <p:nvSpPr>
+          <p:cNvPr id="29" name="Shape 27"/>
+          <p:cNvSpPr/>
+          <p:nvPr/>
+        </p:nvSpPr>
+        <p:spPr>
+          <a:xfrm>
+            <a:off x="566928" y="3849624"/>
+            <a:ext cx="6858000" cy="1371600"/>
+          </a:xfrm>
+          <a:prstGeom prst="roundRect">
+            <a:avLst>
+              <a:gd name="adj" fmla="val 5333"/>
+            </a:avLst>
+          </a:prstGeom>
+          <a:solidFill>
+            <a:srgbClr val="2A1F0B"/>
+          </a:solidFill>
+          <a:ln w="12700">
+            <a:solidFill>
+              <a:srgbClr val="5C4813"/>
+            </a:solidFill>
+            <a:prstDash val="solid"/>
+          </a:ln>
+          <a:effectLst>
+            <a:outerShdw sx="100000" sy="100000" kx="0" ky="0" algn="bl" rotWithShape="0" blurRad="152400" dist="38100" dir="5400000">
+              <a:srgbClr val="000000">
+                <a:alpha val="45000"/>
+              </a:srgbClr>
+            </a:outerShdw>
+          </a:effectLst>
+        </p:spPr>
+      </p:sp>
+      <p:sp>
+        <p:nvSpPr>
+          <p:cNvPr id="30" name="Text 28"/>
+          <p:cNvSpPr/>
+          <p:nvPr/>
+        </p:nvSpPr>
+        <p:spPr>
+          <a:xfrm>
+            <a:off x="822960" y="4014216"/>
+            <a:ext cx="6309360" cy="292608"/>
+          </a:xfrm>
+          <a:prstGeom prst="rect">
+            <a:avLst/>
+          </a:prstGeom>
+          <a:noFill/>
+          <a:ln/>
+        </p:spPr>
+        <p:txBody>
+          <a:bodyPr wrap="square" lIns="0" tIns="0" rIns="0" bIns="0" rtlCol="0" anchor="ctr"/>
+          <a:lstStyle/>
+          <a:p>
+            <a:pPr indent="0" marL="0">
+              <a:buNone/>
+            </a:pPr>
+            <a:r>
+              <a:rPr lang="en-US" sz="1450" b="1" dirty="0">
+                <a:solidFill>
+                  <a:srgbClr val="F0A429"/>
+                </a:solidFill>
+                <a:latin typeface="Arial" pitchFamily="34" charset="0"/>
+                <a:ea typeface="Arial" pitchFamily="34" charset="-122"/>
+                <a:cs typeface="Arial" pitchFamily="34" charset="-120"/>
+              </a:rPr>
+              <a:t>The largest PAX, for the total days</a:t>
+            </a:r>
+            <a:endParaRPr lang="en-US" sz="1450" dirty="0"/>
+          </a:p>
+        </p:txBody>
+      </p:sp>
+      <p:sp>
+        <p:nvSpPr>
+          <p:cNvPr id="31" name="Text 29"/>
+          <p:cNvSpPr/>
+          <p:nvPr/>
+        </p:nvSpPr>
+        <p:spPr>
+          <a:xfrm>
+            <a:off x="822960" y="4361688"/>
+            <a:ext cx="6309360" cy="777240"/>
+          </a:xfrm>
+          <a:prstGeom prst="rect">
+            <a:avLst/>
+          </a:prstGeom>
+          <a:noFill/>
+          <a:ln/>
+        </p:spPr>
+        <p:txBody>
+          <a:bodyPr wrap="square" lIns="0" tIns="0" rIns="0" bIns="0" rtlCol="0" anchor="t"/>
+          <a:lstStyle/>
+          <a:p>
+            <a:pPr algn="l" indent="0" marL="0">
+              <a:lnSpc>
+                <a:spcPts val="1600"/>
+              </a:lnSpc>
+              <a:buNone/>
+            </a:pPr>
+            <a:r>
+              <a:rPr lang="en-US" sz="1200" dirty="0">
+                <a:solidFill>
+                  <a:srgbClr val="E6EDF3"/>
+                </a:solidFill>
+                <a:latin typeface="Calibri" pitchFamily="34" charset="0"/>
+                <a:ea typeface="Calibri" pitchFamily="34" charset="-122"/>
+                <a:cs typeface="Calibri" pitchFamily="34" charset="-120"/>
+              </a:rPr>
+              <a:t>You mobilise 3 electricians for the whole 7 days and pay them whether or not task 1 needs all three. That is why consolidating COSTS MORE than adding the rows up — and why the higher figure is the right one.</a:t>
+            </a:r>
+            <a:endParaRPr lang="en-US" sz="1200" dirty="0"/>
+          </a:p>
+        </p:txBody>
+      </p:sp>
+      <p:sp>
+        <p:nvSpPr>
+          <p:cNvPr id="32" name="Shape 30"/>
+          <p:cNvSpPr/>
+          <p:nvPr/>
+        </p:nvSpPr>
+        <p:spPr>
+          <a:xfrm>
+            <a:off x="7635240" y="1911096"/>
+            <a:ext cx="3977640" cy="1078992"/>
+          </a:xfrm>
+          <a:prstGeom prst="roundRect">
+            <a:avLst>
+              <a:gd name="adj" fmla="val 6780"/>
+            </a:avLst>
+          </a:prstGeom>
+          <a:solidFill>
+            <a:srgbClr val="161B22"/>
+          </a:solidFill>
+          <a:ln w="12700">
+            <a:solidFill>
+              <a:srgbClr val="30363D"/>
+            </a:solidFill>
+            <a:prstDash val="solid"/>
+          </a:ln>
+          <a:effectLst>
+            <a:outerShdw sx="100000" sy="100000" kx="0" ky="0" algn="bl" rotWithShape="0" blurRad="152400" dist="38100" dir="5400000">
+              <a:srgbClr val="000000">
+                <a:alpha val="45000"/>
+              </a:srgbClr>
+            </a:outerShdw>
+          </a:effectLst>
+        </p:spPr>
+      </p:sp>
+      <p:sp>
+        <p:nvSpPr>
+          <p:cNvPr id="33" name="Text 31"/>
+          <p:cNvSpPr/>
+          <p:nvPr/>
+        </p:nvSpPr>
+        <p:spPr>
+          <a:xfrm>
+            <a:off x="7863840" y="2029968"/>
+            <a:ext cx="3566160" cy="274320"/>
+          </a:xfrm>
+          <a:prstGeom prst="rect">
+            <a:avLst/>
+          </a:prstGeom>
+          <a:noFill/>
+          <a:ln/>
+        </p:spPr>
+        <p:txBody>
+          <a:bodyPr wrap="square" lIns="0" tIns="0" rIns="0" bIns="0" rtlCol="0" anchor="ctr"/>
+          <a:lstStyle/>
+          <a:p>
+            <a:pPr indent="0" marL="0">
+              <a:buNone/>
+            </a:pPr>
+            <a:r>
+              <a:rPr lang="en-US" sz="1300" b="1" dirty="0">
+                <a:solidFill>
+                  <a:srgbClr val="F0A429"/>
+                </a:solidFill>
+                <a:latin typeface="Arial" pitchFamily="34" charset="0"/>
+                <a:ea typeface="Arial" pitchFamily="34" charset="-122"/>
+                <a:cs typeface="Arial" pitchFamily="34" charset="-120"/>
+              </a:rPr>
+              <a:t>⇊ Consolidate crew</a:t>
+            </a:r>
+            <a:endParaRPr lang="en-US" sz="1300" dirty="0"/>
+          </a:p>
+        </p:txBody>
+      </p:sp>
+      <p:sp>
+        <p:nvSpPr>
+          <p:cNvPr id="34" name="Text 32"/>
+          <p:cNvSpPr/>
+          <p:nvPr/>
+        </p:nvSpPr>
+        <p:spPr>
+          <a:xfrm>
+            <a:off x="7863840" y="2322576"/>
+            <a:ext cx="3566160" cy="603504"/>
+          </a:xfrm>
+          <a:prstGeom prst="rect">
+            <a:avLst/>
+          </a:prstGeom>
+          <a:noFill/>
+          <a:ln/>
+        </p:spPr>
+        <p:txBody>
+          <a:bodyPr wrap="square" lIns="0" tIns="0" rIns="0" bIns="0" rtlCol="0" anchor="ctr"/>
+          <a:lstStyle/>
+          <a:p>
+            <a:pPr indent="0" marL="0">
+              <a:lnSpc>
+                <a:spcPts val="1350"/>
+              </a:lnSpc>
+              <a:buNone/>
+            </a:pPr>
+            <a:r>
+              <a:rPr lang="en-US" sz="1050" dirty="0">
+                <a:solidFill>
+                  <a:srgbClr val="9AA4AF"/>
+                </a:solidFill>
+                <a:latin typeface="Calibri" pitchFamily="34" charset="0"/>
+                <a:ea typeface="Calibri" pitchFamily="34" charset="-122"/>
+                <a:cs typeface="Calibri" pitchFamily="34" charset="-120"/>
+              </a:rPr>
+              <a:t>On the Manpower tab, under each shift. It shows the arithmetic and warns that the cost will rise before it changes anything.</a:t>
+            </a:r>
+            <a:endParaRPr lang="en-US" sz="1050" dirty="0"/>
+          </a:p>
+        </p:txBody>
+      </p:sp>
+      <p:sp>
+        <p:nvSpPr>
+          <p:cNvPr id="35" name="Shape 33"/>
+          <p:cNvSpPr/>
+          <p:nvPr/>
+        </p:nvSpPr>
+        <p:spPr>
+          <a:xfrm>
+            <a:off x="7635240" y="3118104"/>
+            <a:ext cx="3977640" cy="1078992"/>
+          </a:xfrm>
+          <a:prstGeom prst="roundRect">
+            <a:avLst>
+              <a:gd name="adj" fmla="val 6780"/>
+            </a:avLst>
+          </a:prstGeom>
+          <a:solidFill>
+            <a:srgbClr val="161B22"/>
+          </a:solidFill>
+          <a:ln w="12700">
+            <a:solidFill>
+              <a:srgbClr val="30363D"/>
+            </a:solidFill>
+            <a:prstDash val="solid"/>
+          </a:ln>
+          <a:effectLst>
+            <a:outerShdw sx="100000" sy="100000" kx="0" ky="0" algn="bl" rotWithShape="0" blurRad="152400" dist="38100" dir="5400000">
+              <a:srgbClr val="000000">
+                <a:alpha val="45000"/>
+              </a:srgbClr>
+            </a:outerShdw>
+          </a:effectLst>
+        </p:spPr>
+      </p:sp>
+      <p:sp>
+        <p:nvSpPr>
+          <p:cNvPr id="36" name="Text 34"/>
+          <p:cNvSpPr/>
+          <p:nvPr/>
+        </p:nvSpPr>
+        <p:spPr>
+          <a:xfrm>
+            <a:off x="7863840" y="3236976"/>
+            <a:ext cx="3566160" cy="274320"/>
+          </a:xfrm>
+          <a:prstGeom prst="rect">
+            <a:avLst/>
+          </a:prstGeom>
+          <a:noFill/>
+          <a:ln/>
+        </p:spPr>
+        <p:txBody>
+          <a:bodyPr wrap="square" lIns="0" tIns="0" rIns="0" bIns="0" rtlCol="0" anchor="ctr"/>
+          <a:lstStyle/>
+          <a:p>
+            <a:pPr indent="0" marL="0">
+              <a:buNone/>
+            </a:pPr>
+            <a:r>
+              <a:rPr lang="en-US" sz="1300" b="1" dirty="0">
+                <a:solidFill>
+                  <a:srgbClr val="58A6FF"/>
+                </a:solidFill>
+                <a:latin typeface="Arial" pitchFamily="34" charset="0"/>
+                <a:ea typeface="Arial" pitchFamily="34" charset="-122"/>
+                <a:cs typeface="Arial" pitchFamily="34" charset="-120"/>
+              </a:rPr>
+              <a:t>Tools &amp; Equipment</a:t>
+            </a:r>
+            <a:endParaRPr lang="en-US" sz="1300" dirty="0"/>
+          </a:p>
+        </p:txBody>
+      </p:sp>
+      <p:sp>
+        <p:nvSpPr>
+          <p:cNvPr id="37" name="Text 35"/>
+          <p:cNvSpPr/>
+          <p:nvPr/>
+        </p:nvSpPr>
+        <p:spPr>
+          <a:xfrm>
+            <a:off x="7863840" y="3529584"/>
+            <a:ext cx="3566160" cy="603504"/>
+          </a:xfrm>
+          <a:prstGeom prst="rect">
+            <a:avLst/>
+          </a:prstGeom>
+          <a:noFill/>
+          <a:ln/>
+        </p:spPr>
+        <p:txBody>
+          <a:bodyPr wrap="square" lIns="0" tIns="0" rIns="0" bIns="0" rtlCol="0" anchor="ctr"/>
+          <a:lstStyle/>
+          <a:p>
+            <a:pPr indent="0" marL="0">
+              <a:lnSpc>
+                <a:spcPts val="1350"/>
+              </a:lnSpc>
+              <a:buNone/>
+            </a:pPr>
+            <a:r>
+              <a:rPr lang="en-US" sz="1050" dirty="0">
+                <a:solidFill>
+                  <a:srgbClr val="9AA4AF"/>
+                </a:solidFill>
+                <a:latin typeface="Calibri" pitchFamily="34" charset="0"/>
+                <a:ea typeface="Calibri" pitchFamily="34" charset="-122"/>
+                <a:cs typeface="Calibri" pitchFamily="34" charset="-120"/>
+              </a:rPr>
+              <a:t>Same rule — one compressor covers both tasks. Use ⇊ Combine on that tab.</a:t>
+            </a:r>
+            <a:endParaRPr lang="en-US" sz="1050" dirty="0"/>
+          </a:p>
+        </p:txBody>
+      </p:sp>
+      <p:sp>
+        <p:nvSpPr>
+          <p:cNvPr id="38" name="Shape 36"/>
+          <p:cNvSpPr/>
+          <p:nvPr/>
+        </p:nvSpPr>
+        <p:spPr>
+          <a:xfrm>
+            <a:off x="7635240" y="4325112"/>
+            <a:ext cx="3977640" cy="1078992"/>
+          </a:xfrm>
+          <a:prstGeom prst="roundRect">
+            <a:avLst>
+              <a:gd name="adj" fmla="val 6780"/>
+            </a:avLst>
+          </a:prstGeom>
+          <a:solidFill>
+            <a:srgbClr val="161B22"/>
+          </a:solidFill>
+          <a:ln w="12700">
+            <a:solidFill>
+              <a:srgbClr val="30363D"/>
+            </a:solidFill>
+            <a:prstDash val="solid"/>
+          </a:ln>
+          <a:effectLst>
+            <a:outerShdw sx="100000" sy="100000" kx="0" ky="0" algn="bl" rotWithShape="0" blurRad="152400" dist="38100" dir="5400000">
+              <a:srgbClr val="000000">
+                <a:alpha val="45000"/>
+              </a:srgbClr>
+            </a:outerShdw>
+          </a:effectLst>
+        </p:spPr>
+      </p:sp>
+      <p:sp>
+        <p:nvSpPr>
+          <p:cNvPr id="39" name="Text 37"/>
+          <p:cNvSpPr/>
+          <p:nvPr/>
+        </p:nvSpPr>
+        <p:spPr>
+          <a:xfrm>
+            <a:off x="7863840" y="4443984"/>
+            <a:ext cx="3566160" cy="274320"/>
+          </a:xfrm>
+          <a:prstGeom prst="rect">
+            <a:avLst/>
+          </a:prstGeom>
+          <a:noFill/>
+          <a:ln/>
+        </p:spPr>
+        <p:txBody>
+          <a:bodyPr wrap="square" lIns="0" tIns="0" rIns="0" bIns="0" rtlCol="0" anchor="ctr"/>
+          <a:lstStyle/>
+          <a:p>
+            <a:pPr indent="0" marL="0">
+              <a:buNone/>
+            </a:pPr>
+            <a:r>
+              <a:rPr lang="en-US" sz="1300" b="1" dirty="0">
+                <a:solidFill>
+                  <a:srgbClr val="3FB950"/>
+                </a:solidFill>
+                <a:latin typeface="Arial" pitchFamily="34" charset="0"/>
+                <a:ea typeface="Arial" pitchFamily="34" charset="-122"/>
+                <a:cs typeface="Arial" pitchFamily="34" charset="-120"/>
+              </a:rPr>
+              <a:t>Materials · PPE · Misc.</a:t>
+            </a:r>
+            <a:endParaRPr lang="en-US" sz="1300" dirty="0"/>
+          </a:p>
+        </p:txBody>
+      </p:sp>
+      <p:sp>
+        <p:nvSpPr>
+          <p:cNvPr id="40" name="Text 38"/>
+          <p:cNvSpPr/>
+          <p:nvPr/>
+        </p:nvSpPr>
+        <p:spPr>
+          <a:xfrm>
+            <a:off x="7863840" y="4736592"/>
+            <a:ext cx="3566160" cy="603504"/>
+          </a:xfrm>
+          <a:prstGeom prst="rect">
+            <a:avLst/>
+          </a:prstGeom>
+          <a:noFill/>
+          <a:ln/>
+        </p:spPr>
+        <p:txBody>
+          <a:bodyPr wrap="square" lIns="0" tIns="0" rIns="0" bIns="0" rtlCol="0" anchor="ctr"/>
+          <a:lstStyle/>
+          <a:p>
+            <a:pPr indent="0" marL="0">
+              <a:lnSpc>
+                <a:spcPts val="1350"/>
+              </a:lnSpc>
+              <a:buNone/>
+            </a:pPr>
+            <a:r>
+              <a:rPr lang="en-US" sz="1050" dirty="0">
+                <a:solidFill>
+                  <a:srgbClr val="9AA4AF"/>
+                </a:solidFill>
+                <a:latin typeface="Calibri" pitchFamily="34" charset="0"/>
+                <a:ea typeface="Calibri" pitchFamily="34" charset="-122"/>
+                <a:cs typeface="Calibri" pitchFamily="34" charset="-120"/>
+              </a:rPr>
+              <a:t>The opposite: consumables are used up, so 5 L + 8 L = 13 L and the total does not change.</a:t>
+            </a:r>
+            <a:endParaRPr lang="en-US" sz="1050" dirty="0"/>
+          </a:p>
+        </p:txBody>
+      </p:sp>
+      <p:sp>
+        <p:nvSpPr>
+          <p:cNvPr id="41" name="Shape 39"/>
+          <p:cNvSpPr/>
+          <p:nvPr/>
+        </p:nvSpPr>
+        <p:spPr>
+          <a:xfrm>
+            <a:off x="7635240" y="5522976"/>
+            <a:ext cx="3977640" cy="868680"/>
+          </a:xfrm>
+          <a:prstGeom prst="roundRect">
+            <a:avLst>
+              <a:gd name="adj" fmla="val 8421"/>
+            </a:avLst>
+          </a:prstGeom>
+          <a:solidFill>
+            <a:srgbClr val="161B22"/>
+          </a:solidFill>
+          <a:ln w="12700">
+            <a:solidFill>
+              <a:srgbClr val="30363D"/>
+            </a:solidFill>
+            <a:prstDash val="solid"/>
+          </a:ln>
+          <a:effectLst>
+            <a:outerShdw sx="100000" sy="100000" kx="0" ky="0" algn="bl" rotWithShape="0" blurRad="152400" dist="38100" dir="5400000">
+              <a:srgbClr val="000000">
+                <a:alpha val="45000"/>
+              </a:srgbClr>
+            </a:outerShdw>
+          </a:effectLst>
+        </p:spPr>
+      </p:sp>
+      <p:sp>
+        <p:nvSpPr>
+          <p:cNvPr id="42" name="Text 40"/>
+          <p:cNvSpPr/>
+          <p:nvPr/>
+        </p:nvSpPr>
+        <p:spPr>
+          <a:xfrm>
+            <a:off x="7863840" y="5632704"/>
+            <a:ext cx="3566160" cy="274320"/>
+          </a:xfrm>
+          <a:prstGeom prst="rect">
+            <a:avLst/>
+          </a:prstGeom>
+          <a:noFill/>
+          <a:ln/>
+        </p:spPr>
+        <p:txBody>
+          <a:bodyPr wrap="square" lIns="0" tIns="0" rIns="0" bIns="0" rtlCol="0" anchor="ctr"/>
+          <a:lstStyle/>
+          <a:p>
+            <a:pPr indent="0" marL="0">
+              <a:buNone/>
+            </a:pPr>
+            <a:r>
+              <a:rPr lang="en-US" sz="1300" b="1" dirty="0">
+                <a:solidFill>
+                  <a:srgbClr val="E6EDF3"/>
+                </a:solidFill>
+                <a:latin typeface="Arial" pitchFamily="34" charset="0"/>
+                <a:ea typeface="Arial" pitchFamily="34" charset="-122"/>
+                <a:cs typeface="Arial" pitchFamily="34" charset="-120"/>
+              </a:rPr>
+              <a:t>Your tasks keep their costs</a:t>
+            </a:r>
+            <a:endParaRPr lang="en-US" sz="1300" dirty="0"/>
+          </a:p>
+        </p:txBody>
+      </p:sp>
+      <p:sp>
+        <p:nvSpPr>
+          <p:cNvPr id="43" name="Text 41"/>
+          <p:cNvSpPr/>
+          <p:nvPr/>
+        </p:nvSpPr>
+        <p:spPr>
+          <a:xfrm>
+            <a:off x="7863840" y="5925312"/>
+            <a:ext cx="3566160" cy="411480"/>
+          </a:xfrm>
+          <a:prstGeom prst="rect">
+            <a:avLst/>
+          </a:prstGeom>
+          <a:noFill/>
+          <a:ln/>
+        </p:spPr>
+        <p:txBody>
+          <a:bodyPr wrap="square" lIns="0" tIns="0" rIns="0" bIns="0" rtlCol="0" anchor="ctr"/>
+          <a:lstStyle/>
+          <a:p>
+            <a:pPr indent="0" marL="0">
+              <a:lnSpc>
+                <a:spcPts val="1350"/>
+              </a:lnSpc>
+              <a:buNone/>
+            </a:pPr>
+            <a:r>
+              <a:rPr lang="en-US" sz="1050" dirty="0">
+                <a:solidFill>
+                  <a:srgbClr val="9AA4AF"/>
+                </a:solidFill>
+                <a:latin typeface="Calibri" pitchFamily="34" charset="0"/>
+                <a:ea typeface="Calibri" pitchFamily="34" charset="-122"/>
+                <a:cs typeface="Calibri" pitchFamily="34" charset="-120"/>
+              </a:rPr>
+              <a:t>A consolidated row still appears under every task it serves, split in proportion.</a:t>
+            </a:r>
+            <a:endParaRPr lang="en-US" sz="1050" dirty="0"/>
+          </a:p>
+        </p:txBody>
+      </p:sp>
+      <p:sp>
+        <p:nvSpPr>
+          <p:cNvPr id="44" name="Shape 42"/>
+          <p:cNvSpPr/>
+          <p:nvPr/>
+        </p:nvSpPr>
+        <p:spPr>
+          <a:xfrm>
+            <a:off x="566928" y="5312664"/>
+            <a:ext cx="6858000" cy="896112"/>
+          </a:xfrm>
+          <a:prstGeom prst="roundRect">
+            <a:avLst>
+              <a:gd name="adj" fmla="val 8163"/>
+            </a:avLst>
+          </a:prstGeom>
+          <a:solidFill>
+            <a:srgbClr val="161B22"/>
+          </a:solidFill>
+          <a:ln w="12700">
+            <a:solidFill>
+              <a:srgbClr val="30363D"/>
+            </a:solidFill>
+            <a:prstDash val="solid"/>
+          </a:ln>
+          <a:effectLst>
+            <a:outerShdw sx="100000" sy="100000" kx="0" ky="0" algn="bl" rotWithShape="0" blurRad="152400" dist="38100" dir="5400000">
+              <a:srgbClr val="000000">
+                <a:alpha val="45000"/>
+              </a:srgbClr>
+            </a:outerShdw>
+          </a:effectLst>
+        </p:spPr>
+      </p:sp>
+      <p:sp>
+        <p:nvSpPr>
+          <p:cNvPr id="45" name="Text 43"/>
+          <p:cNvSpPr/>
+          <p:nvPr/>
+        </p:nvSpPr>
+        <p:spPr>
+          <a:xfrm>
+            <a:off x="822960" y="5440680"/>
+            <a:ext cx="6309360" cy="274320"/>
+          </a:xfrm>
+          <a:prstGeom prst="rect">
+            <a:avLst/>
+          </a:prstGeom>
+          <a:noFill/>
+          <a:ln/>
+        </p:spPr>
+        <p:txBody>
+          <a:bodyPr wrap="square" lIns="0" tIns="0" rIns="0" bIns="0" rtlCol="0" anchor="ctr"/>
+          <a:lstStyle/>
+          <a:p>
+            <a:pPr indent="0" marL="0">
+              <a:buNone/>
+            </a:pPr>
+            <a:r>
+              <a:rPr lang="en-US" sz="1350" b="1" dirty="0">
+                <a:solidFill>
+                  <a:srgbClr val="E6EDF3"/>
+                </a:solidFill>
+                <a:latin typeface="Arial" pitchFamily="34" charset="0"/>
+                <a:ea typeface="Arial" pitchFamily="34" charset="-122"/>
+                <a:cs typeface="Arial" pitchFamily="34" charset="-120"/>
+              </a:rPr>
+              <a:t>Do it once, at the end</a:t>
+            </a:r>
+            <a:endParaRPr lang="en-US" sz="1350" dirty="0"/>
+          </a:p>
+        </p:txBody>
+      </p:sp>
+      <p:sp>
+        <p:nvSpPr>
+          <p:cNvPr id="46" name="Text 44"/>
+          <p:cNvSpPr/>
+          <p:nvPr/>
+        </p:nvSpPr>
+        <p:spPr>
+          <a:xfrm>
+            <a:off x="822960" y="5733288"/>
+            <a:ext cx="6309360" cy="457200"/>
+          </a:xfrm>
+          <a:prstGeom prst="rect">
+            <a:avLst/>
+          </a:prstGeom>
+          <a:noFill/>
+          <a:ln/>
+        </p:spPr>
+        <p:txBody>
+          <a:bodyPr wrap="square" lIns="0" tIns="0" rIns="0" bIns="0" rtlCol="0" anchor="t"/>
+          <a:lstStyle/>
+          <a:p>
+            <a:pPr algn="l" indent="0" marL="0">
+              <a:lnSpc>
+                <a:spcPts val="1400"/>
+              </a:lnSpc>
+              <a:buNone/>
+            </a:pPr>
+            <a:r>
+              <a:rPr lang="en-US" sz="1100" dirty="0">
+                <a:solidFill>
+                  <a:srgbClr val="9AA4AF"/>
+                </a:solidFill>
+                <a:latin typeface="Calibri" pitchFamily="34" charset="0"/>
+                <a:ea typeface="Calibri" pitchFamily="34" charset="-122"/>
+                <a:cs typeface="Calibri" pitchFamily="34" charset="-120"/>
+              </a:rPr>
+              <a:t>Plan per task in SOW Breakdown first, then consolidate just before you generate the CE. The printed form shows whatever rows exist when you press Generate.</a:t>
+            </a:r>
+            <a:endParaRPr lang="en-US" sz="1100" dirty="0"/>
+          </a:p>
+        </p:txBody>
+      </p:sp>
+      <p:sp>
+        <p:nvSpPr>
+          <p:cNvPr id="47" name="Text 45"/>
+          <p:cNvSpPr/>
+          <p:nvPr/>
+        </p:nvSpPr>
+        <p:spPr>
+          <a:xfrm>
+            <a:off x="566928" y="6437376"/>
+            <a:ext cx="5486400" cy="237744"/>
+          </a:xfrm>
+          <a:prstGeom prst="rect">
+            <a:avLst/>
+          </a:prstGeom>
+          <a:noFill/>
+          <a:ln/>
+        </p:spPr>
+        <p:txBody>
+          <a:bodyPr wrap="square" lIns="0" tIns="0" rIns="0" bIns="0" rtlCol="0" anchor="ctr"/>
+          <a:lstStyle/>
+          <a:p>
+            <a:pPr indent="0" marL="0">
+              <a:buNone/>
+            </a:pPr>
+            <a:r>
+              <a:rPr lang="en-US" sz="900" dirty="0">
+                <a:solidFill>
+                  <a:srgbClr val="6E7681"/>
+                </a:solidFill>
+                <a:latin typeface="Calibri" pitchFamily="34" charset="0"/>
+                <a:ea typeface="Calibri" pitchFamily="34" charset="-122"/>
+                <a:cs typeface="Calibri" pitchFamily="34" charset="-120"/>
+              </a:rPr>
+              <a:t>SHIC Cost Estimator — End-User Manual</a:t>
+            </a:r>
+            <a:endParaRPr lang="en-US" sz="900" dirty="0"/>
+          </a:p>
+        </p:txBody>
+      </p:sp>
+      <p:sp>
+        <p:nvSpPr>
+          <p:cNvPr id="48" name="Text 46"/>
+          <p:cNvSpPr/>
+          <p:nvPr/>
+        </p:nvSpPr>
+        <p:spPr>
+          <a:xfrm>
+            <a:off x="10981944" y="6437376"/>
+            <a:ext cx="640080" cy="237744"/>
+          </a:xfrm>
+          <a:prstGeom prst="rect">
+            <a:avLst/>
+          </a:prstGeom>
+          <a:noFill/>
+          <a:ln/>
+        </p:spPr>
+        <p:txBody>
+          <a:bodyPr wrap="square" lIns="0" tIns="0" rIns="0" bIns="0" rtlCol="0" anchor="ctr"/>
+          <a:lstStyle/>
+          <a:p>
+            <a:pPr algn="r" indent="0" marL="0">
+              <a:buNone/>
+            </a:pPr>
+            <a:r>
+              <a:rPr lang="en-US" sz="900" dirty="0">
+                <a:solidFill>
+                  <a:srgbClr val="6E7681"/>
+                </a:solidFill>
+                <a:latin typeface="Calibri" pitchFamily="34" charset="0"/>
+                <a:ea typeface="Calibri" pitchFamily="34" charset="-122"/>
+                <a:cs typeface="Calibri" pitchFamily="34" charset="-120"/>
+              </a:rPr>
+              <a:t>10</a:t>
+            </a:r>
+            <a:endParaRPr lang="en-US" sz="900" dirty="0"/>
+          </a:p>
+        </p:txBody>
+      </p:sp>
+    </p:spTree>
+  </p:cSld>
+  <p:clrMapOvr>
+    <a:masterClrMapping/>
+  </p:clrMapOvr>
+</p:sld>
+</file>
+
+<file path=ppt/slides/slide11.xml><?xml version="1.0" encoding="utf-8"?>
+<p:sld xmlns:a="http://schemas.openxmlformats.org/drawingml/2006/main" xmlns:r="http://schemas.openxmlformats.org/officeDocument/2006/relationships" xmlns:p="http://schemas.openxmlformats.org/presentationml/2006/main">
+  <p:cSld name="Slide 11">
+    <p:bg>
+      <p:bgPr>
+        <a:solidFill>
+          <a:srgbClr val="161B22"/>
+        </a:solidFill>
+      </p:bgPr>
+    </p:bg>
+    <p:spTree>
+      <p:nvGrpSpPr>
+        <p:cNvPr id="1" name=""/>
+        <p:cNvGrpSpPr/>
+        <p:nvPr/>
+      </p:nvGrpSpPr>
+      <p:grpSpPr>
+        <a:xfrm>
+          <a:off x="0" y="0"/>
+          <a:ext cx="0" cy="0"/>
+          <a:chOff x="0" y="0"/>
+          <a:chExt cx="0" cy="0"/>
+        </a:xfrm>
+      </p:grpSpPr>
+      <p:sp>
+        <p:nvSpPr>
+          <p:cNvPr id="2" name="Text 0"/>
+          <p:cNvSpPr/>
+          <p:nvPr/>
+        </p:nvSpPr>
+        <p:spPr>
+          <a:xfrm>
+            <a:off x="566928" y="384048"/>
+            <a:ext cx="8229600" cy="256032"/>
+          </a:xfrm>
+          <a:prstGeom prst="rect">
+            <a:avLst/>
+          </a:prstGeom>
+          <a:noFill/>
+          <a:ln/>
+        </p:spPr>
+        <p:txBody>
+          <a:bodyPr wrap="square" lIns="0" tIns="0" rIns="0" bIns="0" rtlCol="0" anchor="ctr"/>
+          <a:lstStyle/>
+          <a:p>
+            <a:pPr indent="0" marL="0">
+              <a:buNone/>
+            </a:pPr>
+            <a:r>
+              <a:rPr lang="en-US" sz="1100" b="1" spc="200" kern="0" dirty="0">
+                <a:solidFill>
+                  <a:srgbClr val="F0A429"/>
+                </a:solidFill>
+                <a:latin typeface="Arial" pitchFamily="34" charset="0"/>
+                <a:ea typeface="Arial" pitchFamily="34" charset="-122"/>
+                <a:cs typeface="Arial" pitchFamily="34" charset="-120"/>
+              </a:rPr>
               <a:t>STEP 5 · TOOLS · MATERIALS · PPE</a:t>
             </a:r>
             <a:endParaRPr lang="en-US" sz="1100" dirty="0"/>
@@ -4216,7 +6072,7 @@
                 <a:ea typeface="Arial" pitchFamily="34" charset="-122"/>
                 <a:cs typeface="Arial" pitchFamily="34" charset="-120"/>
               </a:rPr>
-              <a:t>📥 Import XLS</a:t>
+              <a:t>⇊ Combine</a:t>
             </a:r>
             <a:endParaRPr lang="en-US" sz="1350" dirty="0"/>
           </a:p>
@@ -4258,7 +6114,7 @@
                 <a:ea typeface="Calibri" pitchFamily="34" charset="-122"/>
                 <a:cs typeface="Calibri" pitchFamily="34" charset="-120"/>
               </a:rPr>
-              <a:t>Bulk-load rows from a spreadsheet: Description, Qty, UOM, Unit Cost.</a:t>
+              <a:t>Equipment: largest quantity any task needs, for the total days. Consumables: quantities simply add.</a:t>
             </a:r>
             <a:endParaRPr lang="en-US" sz="1100" dirty="0"/>
           </a:p>
@@ -4451,7 +6307,7 @@
                 <a:ea typeface="Calibri" pitchFamily="34" charset="-122"/>
                 <a:cs typeface="Calibri" pitchFamily="34" charset="-120"/>
               </a:rPr>
-              <a:t>10</a:t>
+              <a:t>11</a:t>
             </a:r>
             <a:endParaRPr lang="en-US" sz="900" dirty="0"/>
           </a:p>
@@ -4465,9 +6321,9 @@
 </p:sld>
 </file>
 
-<file path=ppt/slides/slide11.xml><?xml version="1.0" encoding="utf-8"?>
+<file path=ppt/slides/slide12.xml><?xml version="1.0" encoding="utf-8"?>
 <p:sld xmlns:a="http://schemas.openxmlformats.org/drawingml/2006/main" xmlns:r="http://schemas.openxmlformats.org/officeDocument/2006/relationships" xmlns:p="http://schemas.openxmlformats.org/presentationml/2006/main">
-  <p:cSld name="Slide 11">
+  <p:cSld name="Slide 12">
     <p:bg>
       <p:bgPr>
         <a:solidFill>
@@ -5849,7 +7705,7 @@
                 <a:ea typeface="Calibri" pitchFamily="34" charset="-122"/>
                 <a:cs typeface="Calibri" pitchFamily="34" charset="-120"/>
               </a:rPr>
-              <a:t>11</a:t>
+              <a:t>12</a:t>
             </a:r>
             <a:endParaRPr lang="en-US" sz="900" dirty="0"/>
           </a:p>
@@ -5863,9 +7719,9 @@
 </p:sld>
 </file>
 
-<file path=ppt/slides/slide12.xml><?xml version="1.0" encoding="utf-8"?>
+<file path=ppt/slides/slide13.xml><?xml version="1.0" encoding="utf-8"?>
 <p:sld xmlns:a="http://schemas.openxmlformats.org/drawingml/2006/main" xmlns:r="http://schemas.openxmlformats.org/officeDocument/2006/relationships" xmlns:p="http://schemas.openxmlformats.org/presentationml/2006/main">
-  <p:cSld name="Slide 12">
+  <p:cSld name="Slide 13">
     <p:bg>
       <p:bgPr>
         <a:solidFill>
@@ -7661,7 +9517,7 @@
           <a:ln/>
         </p:spPr>
         <p:txBody>
-          <a:bodyPr wrap="square" lIns="0" tIns="0" rIns="0" bIns="0" rtlCol="0" anchor="ctr"/>
+          <a:bodyPr wrap="square" lIns="0" tIns="0" rIns="0" bIns="0" rtlCol="0" anchor="t"/>
           <a:lstStyle/>
           <a:p>
             <a:pPr marL="342900" indent="-342900">
@@ -7809,7 +9665,7 @@
                 <a:ea typeface="Calibri" pitchFamily="34" charset="-122"/>
                 <a:cs typeface="Calibri" pitchFamily="34" charset="-120"/>
               </a:rPr>
-              <a:t>12</a:t>
+              <a:t>13</a:t>
             </a:r>
             <a:endParaRPr lang="en-US" sz="900" dirty="0"/>
           </a:p>
@@ -7823,9 +9679,9 @@
 </p:sld>
 </file>
 
-<file path=ppt/slides/slide13.xml><?xml version="1.0" encoding="utf-8"?>
+<file path=ppt/slides/slide14.xml><?xml version="1.0" encoding="utf-8"?>
 <p:sld xmlns:a="http://schemas.openxmlformats.org/drawingml/2006/main" xmlns:r="http://schemas.openxmlformats.org/officeDocument/2006/relationships" xmlns:p="http://schemas.openxmlformats.org/presentationml/2006/main">
-  <p:cSld name="Slide 13">
+  <p:cSld name="Slide 14">
     <p:bg>
       <p:bgPr>
         <a:solidFill>
@@ -8058,7 +9914,7 @@
           <a:ln/>
         </p:spPr>
         <p:txBody>
-          <a:bodyPr wrap="square" lIns="0" tIns="0" rIns="0" bIns="0" rtlCol="0" anchor="ctr"/>
+          <a:bodyPr wrap="square" lIns="0" tIns="0" rIns="0" bIns="0" rtlCol="0" anchor="t"/>
           <a:lstStyle/>
           <a:p>
             <a:pPr marL="342900" indent="-342900">
@@ -8249,7 +10105,7 @@
           <a:ln/>
         </p:spPr>
         <p:txBody>
-          <a:bodyPr wrap="square" lIns="0" tIns="0" rIns="0" bIns="0" rtlCol="0" anchor="ctr"/>
+          <a:bodyPr wrap="square" lIns="0" tIns="0" rIns="0" bIns="0" rtlCol="0" anchor="t"/>
           <a:lstStyle/>
           <a:p>
             <a:pPr marL="342900" indent="-342900">
@@ -8536,7 +10392,7 @@
                 <a:ea typeface="Calibri" pitchFamily="34" charset="-122"/>
                 <a:cs typeface="Calibri" pitchFamily="34" charset="-120"/>
               </a:rPr>
-              <a:t>13</a:t>
+              <a:t>14</a:t>
             </a:r>
             <a:endParaRPr lang="en-US" sz="900" dirty="0"/>
           </a:p>
@@ -8550,9 +10406,9 @@
 </p:sld>
 </file>
 
-<file path=ppt/slides/slide14.xml><?xml version="1.0" encoding="utf-8"?>
+<file path=ppt/slides/slide15.xml><?xml version="1.0" encoding="utf-8"?>
 <p:sld xmlns:a="http://schemas.openxmlformats.org/drawingml/2006/main" xmlns:r="http://schemas.openxmlformats.org/officeDocument/2006/relationships" xmlns:p="http://schemas.openxmlformats.org/presentationml/2006/main">
-  <p:cSld name="Slide 14">
+  <p:cSld name="Slide 15">
     <p:bg>
       <p:bgPr>
         <a:solidFill>
@@ -9742,7 +11598,7 @@
                 <a:ea typeface="Calibri" pitchFamily="34" charset="-122"/>
                 <a:cs typeface="Calibri" pitchFamily="34" charset="-120"/>
               </a:rPr>
-              <a:t>14</a:t>
+              <a:t>15</a:t>
             </a:r>
             <a:endParaRPr lang="en-US" sz="900" dirty="0"/>
           </a:p>
@@ -9756,9 +11612,9 @@
 </p:sld>
 </file>
 
-<file path=ppt/slides/slide15.xml><?xml version="1.0" encoding="utf-8"?>
+<file path=ppt/slides/slide16.xml><?xml version="1.0" encoding="utf-8"?>
 <p:sld xmlns:a="http://schemas.openxmlformats.org/drawingml/2006/main" xmlns:r="http://schemas.openxmlformats.org/officeDocument/2006/relationships" xmlns:p="http://schemas.openxmlformats.org/presentationml/2006/main">
-  <p:cSld name="Slide 15">
+  <p:cSld name="Slide 16">
     <p:bg>
       <p:bgPr>
         <a:solidFill>
@@ -10040,7 +11896,7 @@
                 <a:ea typeface="Arial" pitchFamily="34" charset="-122"/>
                 <a:cs typeface="Arial" pitchFamily="34" charset="-120"/>
               </a:rPr>
-              <a:t>Export CE</a:t>
+              <a:t>Export Detailed</a:t>
             </a:r>
             <a:endParaRPr lang="en-US" sz="1500" dirty="0"/>
           </a:p>
@@ -10082,7 +11938,7 @@
                 <a:ea typeface="Calibri" pitchFamily="34" charset="-122"/>
                 <a:cs typeface="Calibri" pitchFamily="34" charset="-120"/>
               </a:rPr>
-              <a:t>Writes an Excel workbook of the same estimate — one sheet per section, for anyone who needs the figures rather than the form.</a:t>
+              <a:t>On the Summary tab. Writes the SAME document as an Excel workbook — one sheet per printed page, same headings, same columns. Figures come through as numbers, so you can total a column.</a:t>
             </a:r>
             <a:endParaRPr lang="en-US" sz="1150" dirty="0"/>
           </a:p>
@@ -10294,7 +12150,7 @@
           <a:ln/>
         </p:spPr>
         <p:txBody>
-          <a:bodyPr wrap="square" lIns="0" tIns="0" rIns="0" bIns="0" rtlCol="0" anchor="ctr"/>
+          <a:bodyPr wrap="square" lIns="0" tIns="0" rIns="0" bIns="0" rtlCol="0" anchor="t"/>
           <a:lstStyle/>
           <a:p>
             <a:pPr marL="342900" indent="-342900">
@@ -10466,7 +12322,7 @@
                 <a:ea typeface="Calibri" pitchFamily="34" charset="-122"/>
                 <a:cs typeface="Calibri" pitchFamily="34" charset="-120"/>
               </a:rPr>
-              <a:t>15</a:t>
+              <a:t>16</a:t>
             </a:r>
             <a:endParaRPr lang="en-US" sz="900" dirty="0"/>
           </a:p>
@@ -10480,9 +12336,9 @@
 </p:sld>
 </file>
 
-<file path=ppt/slides/slide16.xml><?xml version="1.0" encoding="utf-8"?>
+<file path=ppt/slides/slide17.xml><?xml version="1.0" encoding="utf-8"?>
 <p:sld xmlns:a="http://schemas.openxmlformats.org/drawingml/2006/main" xmlns:r="http://schemas.openxmlformats.org/officeDocument/2006/relationships" xmlns:p="http://schemas.openxmlformats.org/presentationml/2006/main">
-  <p:cSld name="Slide 16">
+  <p:cSld name="Slide 17">
     <p:bg>
       <p:bgPr>
         <a:solidFill>
@@ -12125,7 +13981,7 @@
                 <a:ea typeface="Calibri" pitchFamily="34" charset="-122"/>
                 <a:cs typeface="Calibri" pitchFamily="34" charset="-120"/>
               </a:rPr>
-              <a:t>16</a:t>
+              <a:t>17</a:t>
             </a:r>
             <a:endParaRPr lang="en-US" sz="900" dirty="0"/>
           </a:p>
@@ -12139,9 +13995,9 @@
 </p:sld>
 </file>
 
-<file path=ppt/slides/slide17.xml><?xml version="1.0" encoding="utf-8"?>
+<file path=ppt/slides/slide18.xml><?xml version="1.0" encoding="utf-8"?>
 <p:sld xmlns:a="http://schemas.openxmlformats.org/drawingml/2006/main" xmlns:r="http://schemas.openxmlformats.org/officeDocument/2006/relationships" xmlns:p="http://schemas.openxmlformats.org/presentationml/2006/main">
-  <p:cSld name="Slide 17">
+  <p:cSld name="Slide 18">
     <p:bg>
       <p:bgPr>
         <a:solidFill>
@@ -13007,7 +14863,7 @@
                 <a:ea typeface="Calibri" pitchFamily="34" charset="-122"/>
                 <a:cs typeface="Calibri" pitchFamily="34" charset="-120"/>
               </a:rPr>
-              <a:t>17</a:t>
+              <a:t>18</a:t>
             </a:r>
             <a:endParaRPr lang="en-US" sz="900" dirty="0"/>
           </a:p>
@@ -13021,9 +14877,9 @@
 </p:sld>
 </file>
 
-<file path=ppt/slides/slide18.xml><?xml version="1.0" encoding="utf-8"?>
+<file path=ppt/slides/slide19.xml><?xml version="1.0" encoding="utf-8"?>
 <p:sld xmlns:a="http://schemas.openxmlformats.org/drawingml/2006/main" xmlns:r="http://schemas.openxmlformats.org/officeDocument/2006/relationships" xmlns:p="http://schemas.openxmlformats.org/presentationml/2006/main">
-  <p:cSld name="Slide 18">
+  <p:cSld name="Slide 19">
     <p:bg>
       <p:bgPr>
         <a:solidFill>
@@ -14075,618 +15931,6 @@
       <p:sp>
         <p:nvSpPr>
           <p:cNvPr id="30" name="Text 28"/>
-          <p:cNvSpPr/>
-          <p:nvPr/>
-        </p:nvSpPr>
-        <p:spPr>
-          <a:xfrm>
-            <a:off x="10981944" y="6437376"/>
-            <a:ext cx="640080" cy="237744"/>
-          </a:xfrm>
-          <a:prstGeom prst="rect">
-            <a:avLst/>
-          </a:prstGeom>
-          <a:noFill/>
-          <a:ln/>
-        </p:spPr>
-        <p:txBody>
-          <a:bodyPr wrap="square" lIns="0" tIns="0" rIns="0" bIns="0" rtlCol="0" anchor="ctr"/>
-          <a:lstStyle/>
-          <a:p>
-            <a:pPr algn="r" indent="0" marL="0">
-              <a:buNone/>
-            </a:pPr>
-            <a:r>
-              <a:rPr lang="en-US" sz="900" dirty="0">
-                <a:solidFill>
-                  <a:srgbClr val="6E7681"/>
-                </a:solidFill>
-                <a:latin typeface="Calibri" pitchFamily="34" charset="0"/>
-                <a:ea typeface="Calibri" pitchFamily="34" charset="-122"/>
-                <a:cs typeface="Calibri" pitchFamily="34" charset="-120"/>
-              </a:rPr>
-              <a:t>18</a:t>
-            </a:r>
-            <a:endParaRPr lang="en-US" sz="900" dirty="0"/>
-          </a:p>
-        </p:txBody>
-      </p:sp>
-    </p:spTree>
-  </p:cSld>
-  <p:clrMapOvr>
-    <a:masterClrMapping/>
-  </p:clrMapOvr>
-</p:sld>
-</file>
-
-<file path=ppt/slides/slide19.xml><?xml version="1.0" encoding="utf-8"?>
-<p:sld xmlns:a="http://schemas.openxmlformats.org/drawingml/2006/main" xmlns:r="http://schemas.openxmlformats.org/officeDocument/2006/relationships" xmlns:p="http://schemas.openxmlformats.org/presentationml/2006/main">
-  <p:cSld name="Slide 19">
-    <p:bg>
-      <p:bgPr>
-        <a:solidFill>
-          <a:srgbClr val="0D1117"/>
-        </a:solidFill>
-      </p:bgPr>
-    </p:bg>
-    <p:spTree>
-      <p:nvGrpSpPr>
-        <p:cNvPr id="1" name=""/>
-        <p:cNvGrpSpPr/>
-        <p:nvPr/>
-      </p:nvGrpSpPr>
-      <p:grpSpPr>
-        <a:xfrm>
-          <a:off x="0" y="0"/>
-          <a:ext cx="0" cy="0"/>
-          <a:chOff x="0" y="0"/>
-          <a:chExt cx="0" cy="0"/>
-        </a:xfrm>
-      </p:grpSpPr>
-      <p:sp>
-        <p:nvSpPr>
-          <p:cNvPr id="2" name="Text 0"/>
-          <p:cNvSpPr/>
-          <p:nvPr/>
-        </p:nvSpPr>
-        <p:spPr>
-          <a:xfrm>
-            <a:off x="566928" y="384048"/>
-            <a:ext cx="8229600" cy="256032"/>
-          </a:xfrm>
-          <a:prstGeom prst="rect">
-            <a:avLst/>
-          </a:prstGeom>
-          <a:noFill/>
-          <a:ln/>
-        </p:spPr>
-        <p:txBody>
-          <a:bodyPr wrap="square" lIns="0" tIns="0" rIns="0" bIns="0" rtlCol="0" anchor="ctr"/>
-          <a:lstStyle/>
-          <a:p>
-            <a:pPr indent="0" marL="0">
-              <a:buNone/>
-            </a:pPr>
-            <a:r>
-              <a:rPr lang="en-US" sz="1100" b="1" spc="200" kern="0" dirty="0">
-                <a:solidFill>
-                  <a:srgbClr val="F0A429"/>
-                </a:solidFill>
-                <a:latin typeface="Arial" pitchFamily="34" charset="0"/>
-                <a:ea typeface="Arial" pitchFamily="34" charset="-122"/>
-                <a:cs typeface="Arial" pitchFamily="34" charset="-120"/>
-              </a:rPr>
-              <a:t>SCOPE LIBRARY · MASTERLIST</a:t>
-            </a:r>
-            <a:endParaRPr lang="en-US" sz="1100" dirty="0"/>
-          </a:p>
-        </p:txBody>
-      </p:sp>
-      <p:sp>
-        <p:nvSpPr>
-          <p:cNvPr id="3" name="Text 1"/>
-          <p:cNvSpPr/>
-          <p:nvPr/>
-        </p:nvSpPr>
-        <p:spPr>
-          <a:xfrm>
-            <a:off x="566928" y="694944"/>
-            <a:ext cx="11055096" cy="566928"/>
-          </a:xfrm>
-          <a:prstGeom prst="rect">
-            <a:avLst/>
-          </a:prstGeom>
-          <a:noFill/>
-          <a:ln/>
-        </p:spPr>
-        <p:txBody>
-          <a:bodyPr wrap="square" lIns="0" tIns="0" rIns="0" bIns="0" rtlCol="0" anchor="ctr"/>
-          <a:lstStyle/>
-          <a:p>
-            <a:pPr indent="0" marL="0">
-              <a:buNone/>
-            </a:pPr>
-            <a:r>
-              <a:rPr lang="en-US" sz="3200" b="1" dirty="0">
-                <a:solidFill>
-                  <a:srgbClr val="E6EDF3"/>
-                </a:solidFill>
-                <a:latin typeface="Arial" pitchFamily="34" charset="0"/>
-                <a:ea typeface="Arial" pitchFamily="34" charset="-122"/>
-                <a:cs typeface="Arial" pitchFamily="34" charset="-120"/>
-              </a:rPr>
-              <a:t>Keeping the shared lists right</a:t>
-            </a:r>
-            <a:endParaRPr lang="en-US" sz="3200" dirty="0"/>
-          </a:p>
-        </p:txBody>
-      </p:sp>
-      <p:sp>
-        <p:nvSpPr>
-          <p:cNvPr id="4" name="Text 2"/>
-          <p:cNvSpPr/>
-          <p:nvPr/>
-        </p:nvSpPr>
-        <p:spPr>
-          <a:xfrm>
-            <a:off x="566928" y="1298448"/>
-            <a:ext cx="10972800" cy="365760"/>
-          </a:xfrm>
-          <a:prstGeom prst="rect">
-            <a:avLst/>
-          </a:prstGeom>
-          <a:noFill/>
-          <a:ln/>
-        </p:spPr>
-        <p:txBody>
-          <a:bodyPr wrap="square" lIns="0" tIns="0" rIns="0" bIns="0" rtlCol="0" anchor="t"/>
-          <a:lstStyle/>
-          <a:p>
-            <a:pPr algn="l" indent="0" marL="0">
-              <a:lnSpc>
-                <a:spcPts val="2000"/>
-              </a:lnSpc>
-              <a:buNone/>
-            </a:pPr>
-            <a:r>
-              <a:rPr lang="en-US" sz="1400" dirty="0">
-                <a:solidFill>
-                  <a:srgbClr val="9AA4AF"/>
-                </a:solidFill>
-                <a:latin typeface="Calibri" pitchFamily="34" charset="0"/>
-                <a:ea typeface="Calibri" pitchFamily="34" charset="-122"/>
-                <a:cs typeface="Calibri" pitchFamily="34" charset="-120"/>
-              </a:rPr>
-              <a:t>These two lists are shared by everyone. A change here changes what every estimator sees next time.</a:t>
-            </a:r>
-            <a:endParaRPr lang="en-US" sz="1400" dirty="0"/>
-          </a:p>
-        </p:txBody>
-      </p:sp>
-      <p:sp>
-        <p:nvSpPr>
-          <p:cNvPr id="5" name="Shape 3"/>
-          <p:cNvSpPr/>
-          <p:nvPr/>
-        </p:nvSpPr>
-        <p:spPr>
-          <a:xfrm>
-            <a:off x="566928" y="1911096"/>
-            <a:ext cx="5532120" cy="3566160"/>
-          </a:xfrm>
-          <a:prstGeom prst="roundRect">
-            <a:avLst>
-              <a:gd name="adj" fmla="val 2051"/>
-            </a:avLst>
-          </a:prstGeom>
-          <a:solidFill>
-            <a:srgbClr val="1C2128"/>
-          </a:solidFill>
-          <a:ln w="12700">
-            <a:solidFill>
-              <a:srgbClr val="30363D"/>
-            </a:solidFill>
-            <a:prstDash val="solid"/>
-          </a:ln>
-          <a:effectLst>
-            <a:outerShdw sx="100000" sy="100000" kx="0" ky="0" algn="bl" rotWithShape="0" blurRad="152400" dist="38100" dir="5400000">
-              <a:srgbClr val="000000">
-                <a:alpha val="45000"/>
-              </a:srgbClr>
-            </a:outerShdw>
-          </a:effectLst>
-        </p:spPr>
-      </p:sp>
-      <p:sp>
-        <p:nvSpPr>
-          <p:cNvPr id="6" name="Text 4"/>
-          <p:cNvSpPr/>
-          <p:nvPr/>
-        </p:nvSpPr>
-        <p:spPr>
-          <a:xfrm>
-            <a:off x="841248" y="2121408"/>
-            <a:ext cx="4937760" cy="329184"/>
-          </a:xfrm>
-          <a:prstGeom prst="rect">
-            <a:avLst/>
-          </a:prstGeom>
-          <a:noFill/>
-          <a:ln/>
-        </p:spPr>
-        <p:txBody>
-          <a:bodyPr wrap="square" lIns="0" tIns="0" rIns="0" bIns="0" rtlCol="0" anchor="ctr"/>
-          <a:lstStyle/>
-          <a:p>
-            <a:pPr indent="0" marL="0">
-              <a:buNone/>
-            </a:pPr>
-            <a:r>
-              <a:rPr lang="en-US" sz="1700" b="1" dirty="0">
-                <a:solidFill>
-                  <a:srgbClr val="A78BFA"/>
-                </a:solidFill>
-                <a:latin typeface="Arial" pitchFamily="34" charset="0"/>
-                <a:ea typeface="Arial" pitchFamily="34" charset="-122"/>
-                <a:cs typeface="Arial" pitchFamily="34" charset="-120"/>
-              </a:rPr>
-              <a:t>Scope Library</a:t>
-            </a:r>
-            <a:endParaRPr lang="en-US" sz="1700" dirty="0"/>
-          </a:p>
-        </p:txBody>
-      </p:sp>
-      <p:sp>
-        <p:nvSpPr>
-          <p:cNvPr id="7" name="Text 5"/>
-          <p:cNvSpPr/>
-          <p:nvPr/>
-        </p:nvSpPr>
-        <p:spPr>
-          <a:xfrm>
-            <a:off x="841248" y="2578608"/>
-            <a:ext cx="4983480" cy="2651760"/>
-          </a:xfrm>
-          <a:prstGeom prst="rect">
-            <a:avLst/>
-          </a:prstGeom>
-          <a:noFill/>
-          <a:ln/>
-        </p:spPr>
-        <p:txBody>
-          <a:bodyPr wrap="square" lIns="0" tIns="0" rIns="0" bIns="0" rtlCol="0" anchor="ctr"/>
-          <a:lstStyle/>
-          <a:p>
-            <a:pPr marL="342900" indent="-342900">
-              <a:lnSpc>
-                <a:spcPts val="1600"/>
-              </a:lnSpc>
-              <a:spcAft>
-                <a:spcPts val="900"/>
-              </a:spcAft>
-              <a:buSzPct val="100000"/>
-              <a:buChar char="●"/>
-            </a:pPr>
-            <a:r>
-              <a:rPr lang="en-US" sz="1200" dirty="0">
-                <a:solidFill>
-                  <a:srgbClr val="E6EDF3"/>
-                </a:solidFill>
-                <a:latin typeface="Calibri" pitchFamily="34" charset="0"/>
-                <a:ea typeface="Calibri" pitchFamily="34" charset="-122"/>
-                <a:cs typeface="Calibri" pitchFamily="34" charset="-120"/>
-              </a:rPr>
-              <a:t>One card per standard service. Click Edit to open it where it sits</a:t>
-            </a:r>
-            <a:endParaRPr lang="en-US" sz="1200" dirty="0"/>
-          </a:p>
-          <a:p>
-            <a:pPr marL="342900" indent="-342900">
-              <a:lnSpc>
-                <a:spcPts val="1600"/>
-              </a:lnSpc>
-              <a:spcAft>
-                <a:spcPts val="900"/>
-              </a:spcAft>
-              <a:buSzPct val="100000"/>
-              <a:buChar char="●"/>
-            </a:pPr>
-            <a:r>
-              <a:rPr lang="en-US" sz="1200" dirty="0">
-                <a:solidFill>
-                  <a:srgbClr val="E6EDF3"/>
-                </a:solidFill>
-                <a:latin typeface="Calibri" pitchFamily="34" charset="0"/>
-                <a:ea typeface="Calibri" pitchFamily="34" charset="-122"/>
-                <a:cs typeface="Calibri" pitchFamily="34" charset="-120"/>
-              </a:rPr>
-              <a:t>A new service is added at the top, already open</a:t>
-            </a:r>
-            <a:endParaRPr lang="en-US" sz="1200" dirty="0"/>
-          </a:p>
-          <a:p>
-            <a:pPr marL="342900" indent="-342900">
-              <a:lnSpc>
-                <a:spcPts val="1600"/>
-              </a:lnSpc>
-              <a:spcAft>
-                <a:spcPts val="900"/>
-              </a:spcAft>
-              <a:buSzPct val="100000"/>
-              <a:buChar char="●"/>
-            </a:pPr>
-            <a:r>
-              <a:rPr lang="en-US" sz="1200" dirty="0">
-                <a:solidFill>
-                  <a:srgbClr val="E6EDF3"/>
-                </a:solidFill>
-                <a:latin typeface="Calibri" pitchFamily="34" charset="0"/>
-                <a:ea typeface="Calibri" pitchFamily="34" charset="-122"/>
-                <a:cs typeface="Calibri" pitchFamily="34" charset="-120"/>
-              </a:rPr>
-              <a:t>Resources belong to a scope step, so applying the service files them against the right task</a:t>
-            </a:r>
-            <a:endParaRPr lang="en-US" sz="1200" dirty="0"/>
-          </a:p>
-          <a:p>
-            <a:pPr marL="342900" indent="-342900">
-              <a:lnSpc>
-                <a:spcPts val="1600"/>
-              </a:lnSpc>
-              <a:spcAft>
-                <a:spcPts val="900"/>
-              </a:spcAft>
-              <a:buSzPct val="100000"/>
-              <a:buChar char="●"/>
-            </a:pPr>
-            <a:r>
-              <a:rPr lang="en-US" sz="1200" dirty="0">
-                <a:solidFill>
-                  <a:srgbClr val="E6EDF3"/>
-                </a:solidFill>
-                <a:latin typeface="Calibri" pitchFamily="34" charset="0"/>
-                <a:ea typeface="Calibri" pitchFamily="34" charset="-122"/>
-                <a:cs typeface="Calibri" pitchFamily="34" charset="-120"/>
-              </a:rPr>
-              <a:t>Leave a manpower row's Days blank if that role is on site for the whole project; enter a number if it is only needed for its step</a:t>
-            </a:r>
-            <a:endParaRPr lang="en-US" sz="1200" dirty="0"/>
-          </a:p>
-        </p:txBody>
-      </p:sp>
-      <p:sp>
-        <p:nvSpPr>
-          <p:cNvPr id="8" name="Shape 6"/>
-          <p:cNvSpPr/>
-          <p:nvPr/>
-        </p:nvSpPr>
-        <p:spPr>
-          <a:xfrm>
-            <a:off x="6400800" y="1911096"/>
-            <a:ext cx="5221224" cy="3566160"/>
-          </a:xfrm>
-          <a:prstGeom prst="roundRect">
-            <a:avLst>
-              <a:gd name="adj" fmla="val 2051"/>
-            </a:avLst>
-          </a:prstGeom>
-          <a:solidFill>
-            <a:srgbClr val="1C2128"/>
-          </a:solidFill>
-          <a:ln w="12700">
-            <a:solidFill>
-              <a:srgbClr val="30363D"/>
-            </a:solidFill>
-            <a:prstDash val="solid"/>
-          </a:ln>
-          <a:effectLst>
-            <a:outerShdw sx="100000" sy="100000" kx="0" ky="0" algn="bl" rotWithShape="0" blurRad="152400" dist="38100" dir="5400000">
-              <a:srgbClr val="000000">
-                <a:alpha val="45000"/>
-              </a:srgbClr>
-            </a:outerShdw>
-          </a:effectLst>
-        </p:spPr>
-      </p:sp>
-      <p:sp>
-        <p:nvSpPr>
-          <p:cNvPr id="9" name="Text 7"/>
-          <p:cNvSpPr/>
-          <p:nvPr/>
-        </p:nvSpPr>
-        <p:spPr>
-          <a:xfrm>
-            <a:off x="6675120" y="2121408"/>
-            <a:ext cx="4663440" cy="329184"/>
-          </a:xfrm>
-          <a:prstGeom prst="rect">
-            <a:avLst/>
-          </a:prstGeom>
-          <a:noFill/>
-          <a:ln/>
-        </p:spPr>
-        <p:txBody>
-          <a:bodyPr wrap="square" lIns="0" tIns="0" rIns="0" bIns="0" rtlCol="0" anchor="ctr"/>
-          <a:lstStyle/>
-          <a:p>
-            <a:pPr indent="0" marL="0">
-              <a:buNone/>
-            </a:pPr>
-            <a:r>
-              <a:rPr lang="en-US" sz="1700" b="1" dirty="0">
-                <a:solidFill>
-                  <a:srgbClr val="F0A429"/>
-                </a:solidFill>
-                <a:latin typeface="Arial" pitchFamily="34" charset="0"/>
-                <a:ea typeface="Arial" pitchFamily="34" charset="-122"/>
-                <a:cs typeface="Arial" pitchFamily="34" charset="-120"/>
-              </a:rPr>
-              <a:t>Masterlist</a:t>
-            </a:r>
-            <a:endParaRPr lang="en-US" sz="1700" dirty="0"/>
-          </a:p>
-        </p:txBody>
-      </p:sp>
-      <p:sp>
-        <p:nvSpPr>
-          <p:cNvPr id="10" name="Text 8"/>
-          <p:cNvSpPr/>
-          <p:nvPr/>
-        </p:nvSpPr>
-        <p:spPr>
-          <a:xfrm>
-            <a:off x="6675120" y="2578608"/>
-            <a:ext cx="4709160" cy="2651760"/>
-          </a:xfrm>
-          <a:prstGeom prst="rect">
-            <a:avLst/>
-          </a:prstGeom>
-          <a:noFill/>
-          <a:ln/>
-        </p:spPr>
-        <p:txBody>
-          <a:bodyPr wrap="square" lIns="0" tIns="0" rIns="0" bIns="0" rtlCol="0" anchor="ctr"/>
-          <a:lstStyle/>
-          <a:p>
-            <a:pPr marL="342900" indent="-342900">
-              <a:lnSpc>
-                <a:spcPts val="1600"/>
-              </a:lnSpc>
-              <a:spcAft>
-                <a:spcPts val="900"/>
-              </a:spcAft>
-              <a:buSzPct val="100000"/>
-              <a:buChar char="●"/>
-            </a:pPr>
-            <a:r>
-              <a:rPr lang="en-US" sz="1200" dirty="0">
-                <a:solidFill>
-                  <a:srgbClr val="E6EDF3"/>
-                </a:solidFill>
-                <a:latin typeface="Calibri" pitchFamily="34" charset="0"/>
-                <a:ea typeface="Calibri" pitchFamily="34" charset="-122"/>
-                <a:cs typeface="Calibri" pitchFamily="34" charset="-120"/>
-              </a:rPr>
-              <a:t>The single source of rates for manpower, tools, materials and PPE</a:t>
-            </a:r>
-            <a:endParaRPr lang="en-US" sz="1200" dirty="0"/>
-          </a:p>
-          <a:p>
-            <a:pPr marL="342900" indent="-342900">
-              <a:lnSpc>
-                <a:spcPts val="1600"/>
-              </a:lnSpc>
-              <a:spcAft>
-                <a:spcPts val="900"/>
-              </a:spcAft>
-              <a:buSzPct val="100000"/>
-              <a:buChar char="●"/>
-            </a:pPr>
-            <a:r>
-              <a:rPr lang="en-US" sz="1200" dirty="0">
-                <a:solidFill>
-                  <a:srgbClr val="E6EDF3"/>
-                </a:solidFill>
-                <a:latin typeface="Calibri" pitchFamily="34" charset="0"/>
-                <a:ea typeface="Calibri" pitchFamily="34" charset="-122"/>
-                <a:cs typeface="Calibri" pitchFamily="34" charset="-120"/>
-              </a:rPr>
-              <a:t>Every rate you pick in a CE comes from here</a:t>
-            </a:r>
-            <a:endParaRPr lang="en-US" sz="1200" dirty="0"/>
-          </a:p>
-          <a:p>
-            <a:pPr marL="342900" indent="-342900">
-              <a:lnSpc>
-                <a:spcPts val="1600"/>
-              </a:lnSpc>
-              <a:spcAft>
-                <a:spcPts val="900"/>
-              </a:spcAft>
-              <a:buSzPct val="100000"/>
-              <a:buChar char="●"/>
-            </a:pPr>
-            <a:r>
-              <a:rPr lang="en-US" sz="1200" dirty="0">
-                <a:solidFill>
-                  <a:srgbClr val="E6EDF3"/>
-                </a:solidFill>
-                <a:latin typeface="Calibri" pitchFamily="34" charset="0"/>
-                <a:ea typeface="Calibri" pitchFamily="34" charset="-122"/>
-                <a:cs typeface="Calibri" pitchFamily="34" charset="-120"/>
-              </a:rPr>
-              <a:t>Update a rate once and use ↺ Sync Rates on an older CE to bring it up to date</a:t>
-            </a:r>
-            <a:endParaRPr lang="en-US" sz="1200" dirty="0"/>
-          </a:p>
-          <a:p>
-            <a:pPr marL="342900" indent="-342900">
-              <a:lnSpc>
-                <a:spcPts val="1600"/>
-              </a:lnSpc>
-              <a:spcAft>
-                <a:spcPts val="900"/>
-              </a:spcAft>
-              <a:buSzPct val="100000"/>
-              <a:buChar char="●"/>
-            </a:pPr>
-            <a:r>
-              <a:rPr lang="en-US" sz="1200" dirty="0">
-                <a:solidFill>
-                  <a:srgbClr val="E6EDF3"/>
-                </a:solidFill>
-                <a:latin typeface="Calibri" pitchFamily="34" charset="0"/>
-                <a:ea typeface="Calibri" pitchFamily="34" charset="-122"/>
-                <a:cs typeface="Calibri" pitchFamily="34" charset="-120"/>
-              </a:rPr>
-              <a:t>Changing a rate does not alter CEs already saved</a:t>
-            </a:r>
-            <a:endParaRPr lang="en-US" sz="1200" dirty="0"/>
-          </a:p>
-        </p:txBody>
-      </p:sp>
-      <p:sp>
-        <p:nvSpPr>
-          <p:cNvPr id="11" name="Text 9"/>
-          <p:cNvSpPr/>
-          <p:nvPr/>
-        </p:nvSpPr>
-        <p:spPr>
-          <a:xfrm>
-            <a:off x="566928" y="6437376"/>
-            <a:ext cx="5486400" cy="237744"/>
-          </a:xfrm>
-          <a:prstGeom prst="rect">
-            <a:avLst/>
-          </a:prstGeom>
-          <a:noFill/>
-          <a:ln/>
-        </p:spPr>
-        <p:txBody>
-          <a:bodyPr wrap="square" lIns="0" tIns="0" rIns="0" bIns="0" rtlCol="0" anchor="ctr"/>
-          <a:lstStyle/>
-          <a:p>
-            <a:pPr indent="0" marL="0">
-              <a:buNone/>
-            </a:pPr>
-            <a:r>
-              <a:rPr lang="en-US" sz="900" dirty="0">
-                <a:solidFill>
-                  <a:srgbClr val="6E7681"/>
-                </a:solidFill>
-                <a:latin typeface="Calibri" pitchFamily="34" charset="0"/>
-                <a:ea typeface="Calibri" pitchFamily="34" charset="-122"/>
-                <a:cs typeface="Calibri" pitchFamily="34" charset="-120"/>
-              </a:rPr>
-              <a:t>SHIC Cost Estimator — End-User Manual</a:t>
-            </a:r>
-            <a:endParaRPr lang="en-US" sz="900" dirty="0"/>
-          </a:p>
-        </p:txBody>
-      </p:sp>
-      <p:sp>
-        <p:nvSpPr>
-          <p:cNvPr id="12" name="Text 10"/>
           <p:cNvSpPr/>
           <p:nvPr/>
         </p:nvSpPr>
@@ -14924,7 +16168,7 @@
           <a:ln/>
         </p:spPr>
         <p:txBody>
-          <a:bodyPr wrap="square" lIns="0" tIns="0" rIns="0" bIns="0" rtlCol="0" anchor="ctr"/>
+          <a:bodyPr wrap="square" lIns="0" tIns="0" rIns="0" bIns="0" rtlCol="0" anchor="t"/>
           <a:lstStyle/>
           <a:p>
             <a:pPr marL="342900" indent="-342900">
@@ -15575,6 +16819,618 @@
 <file path=ppt/slides/slide20.xml><?xml version="1.0" encoding="utf-8"?>
 <p:sld xmlns:a="http://schemas.openxmlformats.org/drawingml/2006/main" xmlns:r="http://schemas.openxmlformats.org/officeDocument/2006/relationships" xmlns:p="http://schemas.openxmlformats.org/presentationml/2006/main">
   <p:cSld name="Slide 20">
+    <p:bg>
+      <p:bgPr>
+        <a:solidFill>
+          <a:srgbClr val="0D1117"/>
+        </a:solidFill>
+      </p:bgPr>
+    </p:bg>
+    <p:spTree>
+      <p:nvGrpSpPr>
+        <p:cNvPr id="1" name=""/>
+        <p:cNvGrpSpPr/>
+        <p:nvPr/>
+      </p:nvGrpSpPr>
+      <p:grpSpPr>
+        <a:xfrm>
+          <a:off x="0" y="0"/>
+          <a:ext cx="0" cy="0"/>
+          <a:chOff x="0" y="0"/>
+          <a:chExt cx="0" cy="0"/>
+        </a:xfrm>
+      </p:grpSpPr>
+      <p:sp>
+        <p:nvSpPr>
+          <p:cNvPr id="2" name="Text 0"/>
+          <p:cNvSpPr/>
+          <p:nvPr/>
+        </p:nvSpPr>
+        <p:spPr>
+          <a:xfrm>
+            <a:off x="566928" y="384048"/>
+            <a:ext cx="8229600" cy="256032"/>
+          </a:xfrm>
+          <a:prstGeom prst="rect">
+            <a:avLst/>
+          </a:prstGeom>
+          <a:noFill/>
+          <a:ln/>
+        </p:spPr>
+        <p:txBody>
+          <a:bodyPr wrap="square" lIns="0" tIns="0" rIns="0" bIns="0" rtlCol="0" anchor="ctr"/>
+          <a:lstStyle/>
+          <a:p>
+            <a:pPr indent="0" marL="0">
+              <a:buNone/>
+            </a:pPr>
+            <a:r>
+              <a:rPr lang="en-US" sz="1100" b="1" spc="200" kern="0" dirty="0">
+                <a:solidFill>
+                  <a:srgbClr val="F0A429"/>
+                </a:solidFill>
+                <a:latin typeface="Arial" pitchFamily="34" charset="0"/>
+                <a:ea typeface="Arial" pitchFamily="34" charset="-122"/>
+                <a:cs typeface="Arial" pitchFamily="34" charset="-120"/>
+              </a:rPr>
+              <a:t>SCOPE LIBRARY · MASTERLIST</a:t>
+            </a:r>
+            <a:endParaRPr lang="en-US" sz="1100" dirty="0"/>
+          </a:p>
+        </p:txBody>
+      </p:sp>
+      <p:sp>
+        <p:nvSpPr>
+          <p:cNvPr id="3" name="Text 1"/>
+          <p:cNvSpPr/>
+          <p:nvPr/>
+        </p:nvSpPr>
+        <p:spPr>
+          <a:xfrm>
+            <a:off x="566928" y="694944"/>
+            <a:ext cx="11055096" cy="566928"/>
+          </a:xfrm>
+          <a:prstGeom prst="rect">
+            <a:avLst/>
+          </a:prstGeom>
+          <a:noFill/>
+          <a:ln/>
+        </p:spPr>
+        <p:txBody>
+          <a:bodyPr wrap="square" lIns="0" tIns="0" rIns="0" bIns="0" rtlCol="0" anchor="ctr"/>
+          <a:lstStyle/>
+          <a:p>
+            <a:pPr indent="0" marL="0">
+              <a:buNone/>
+            </a:pPr>
+            <a:r>
+              <a:rPr lang="en-US" sz="3200" b="1" dirty="0">
+                <a:solidFill>
+                  <a:srgbClr val="E6EDF3"/>
+                </a:solidFill>
+                <a:latin typeface="Arial" pitchFamily="34" charset="0"/>
+                <a:ea typeface="Arial" pitchFamily="34" charset="-122"/>
+                <a:cs typeface="Arial" pitchFamily="34" charset="-120"/>
+              </a:rPr>
+              <a:t>Keeping the shared lists right</a:t>
+            </a:r>
+            <a:endParaRPr lang="en-US" sz="3200" dirty="0"/>
+          </a:p>
+        </p:txBody>
+      </p:sp>
+      <p:sp>
+        <p:nvSpPr>
+          <p:cNvPr id="4" name="Text 2"/>
+          <p:cNvSpPr/>
+          <p:nvPr/>
+        </p:nvSpPr>
+        <p:spPr>
+          <a:xfrm>
+            <a:off x="566928" y="1298448"/>
+            <a:ext cx="10972800" cy="365760"/>
+          </a:xfrm>
+          <a:prstGeom prst="rect">
+            <a:avLst/>
+          </a:prstGeom>
+          <a:noFill/>
+          <a:ln/>
+        </p:spPr>
+        <p:txBody>
+          <a:bodyPr wrap="square" lIns="0" tIns="0" rIns="0" bIns="0" rtlCol="0" anchor="t"/>
+          <a:lstStyle/>
+          <a:p>
+            <a:pPr algn="l" indent="0" marL="0">
+              <a:lnSpc>
+                <a:spcPts val="2000"/>
+              </a:lnSpc>
+              <a:buNone/>
+            </a:pPr>
+            <a:r>
+              <a:rPr lang="en-US" sz="1400" dirty="0">
+                <a:solidFill>
+                  <a:srgbClr val="9AA4AF"/>
+                </a:solidFill>
+                <a:latin typeface="Calibri" pitchFamily="34" charset="0"/>
+                <a:ea typeface="Calibri" pitchFamily="34" charset="-122"/>
+                <a:cs typeface="Calibri" pitchFamily="34" charset="-120"/>
+              </a:rPr>
+              <a:t>These two lists are shared by everyone. A change here changes what every estimator sees next time.</a:t>
+            </a:r>
+            <a:endParaRPr lang="en-US" sz="1400" dirty="0"/>
+          </a:p>
+        </p:txBody>
+      </p:sp>
+      <p:sp>
+        <p:nvSpPr>
+          <p:cNvPr id="5" name="Shape 3"/>
+          <p:cNvSpPr/>
+          <p:nvPr/>
+        </p:nvSpPr>
+        <p:spPr>
+          <a:xfrm>
+            <a:off x="566928" y="1911096"/>
+            <a:ext cx="5532120" cy="3566160"/>
+          </a:xfrm>
+          <a:prstGeom prst="roundRect">
+            <a:avLst>
+              <a:gd name="adj" fmla="val 2051"/>
+            </a:avLst>
+          </a:prstGeom>
+          <a:solidFill>
+            <a:srgbClr val="1C2128"/>
+          </a:solidFill>
+          <a:ln w="12700">
+            <a:solidFill>
+              <a:srgbClr val="30363D"/>
+            </a:solidFill>
+            <a:prstDash val="solid"/>
+          </a:ln>
+          <a:effectLst>
+            <a:outerShdw sx="100000" sy="100000" kx="0" ky="0" algn="bl" rotWithShape="0" blurRad="152400" dist="38100" dir="5400000">
+              <a:srgbClr val="000000">
+                <a:alpha val="45000"/>
+              </a:srgbClr>
+            </a:outerShdw>
+          </a:effectLst>
+        </p:spPr>
+      </p:sp>
+      <p:sp>
+        <p:nvSpPr>
+          <p:cNvPr id="6" name="Text 4"/>
+          <p:cNvSpPr/>
+          <p:nvPr/>
+        </p:nvSpPr>
+        <p:spPr>
+          <a:xfrm>
+            <a:off x="841248" y="2121408"/>
+            <a:ext cx="4937760" cy="329184"/>
+          </a:xfrm>
+          <a:prstGeom prst="rect">
+            <a:avLst/>
+          </a:prstGeom>
+          <a:noFill/>
+          <a:ln/>
+        </p:spPr>
+        <p:txBody>
+          <a:bodyPr wrap="square" lIns="0" tIns="0" rIns="0" bIns="0" rtlCol="0" anchor="ctr"/>
+          <a:lstStyle/>
+          <a:p>
+            <a:pPr indent="0" marL="0">
+              <a:buNone/>
+            </a:pPr>
+            <a:r>
+              <a:rPr lang="en-US" sz="1700" b="1" dirty="0">
+                <a:solidFill>
+                  <a:srgbClr val="A78BFA"/>
+                </a:solidFill>
+                <a:latin typeface="Arial" pitchFamily="34" charset="0"/>
+                <a:ea typeface="Arial" pitchFamily="34" charset="-122"/>
+                <a:cs typeface="Arial" pitchFamily="34" charset="-120"/>
+              </a:rPr>
+              <a:t>Scope Library</a:t>
+            </a:r>
+            <a:endParaRPr lang="en-US" sz="1700" dirty="0"/>
+          </a:p>
+        </p:txBody>
+      </p:sp>
+      <p:sp>
+        <p:nvSpPr>
+          <p:cNvPr id="7" name="Text 5"/>
+          <p:cNvSpPr/>
+          <p:nvPr/>
+        </p:nvSpPr>
+        <p:spPr>
+          <a:xfrm>
+            <a:off x="841248" y="2578608"/>
+            <a:ext cx="4983480" cy="2651760"/>
+          </a:xfrm>
+          <a:prstGeom prst="rect">
+            <a:avLst/>
+          </a:prstGeom>
+          <a:noFill/>
+          <a:ln/>
+        </p:spPr>
+        <p:txBody>
+          <a:bodyPr wrap="square" lIns="0" tIns="0" rIns="0" bIns="0" rtlCol="0" anchor="t"/>
+          <a:lstStyle/>
+          <a:p>
+            <a:pPr marL="342900" indent="-342900">
+              <a:lnSpc>
+                <a:spcPts val="1600"/>
+              </a:lnSpc>
+              <a:spcAft>
+                <a:spcPts val="900"/>
+              </a:spcAft>
+              <a:buSzPct val="100000"/>
+              <a:buChar char="●"/>
+            </a:pPr>
+            <a:r>
+              <a:rPr lang="en-US" sz="1200" dirty="0">
+                <a:solidFill>
+                  <a:srgbClr val="E6EDF3"/>
+                </a:solidFill>
+                <a:latin typeface="Calibri" pitchFamily="34" charset="0"/>
+                <a:ea typeface="Calibri" pitchFamily="34" charset="-122"/>
+                <a:cs typeface="Calibri" pitchFamily="34" charset="-120"/>
+              </a:rPr>
+              <a:t>One card per standard service. Click Edit to open it where it sits</a:t>
+            </a:r>
+            <a:endParaRPr lang="en-US" sz="1200" dirty="0"/>
+          </a:p>
+          <a:p>
+            <a:pPr marL="342900" indent="-342900">
+              <a:lnSpc>
+                <a:spcPts val="1600"/>
+              </a:lnSpc>
+              <a:spcAft>
+                <a:spcPts val="900"/>
+              </a:spcAft>
+              <a:buSzPct val="100000"/>
+              <a:buChar char="●"/>
+            </a:pPr>
+            <a:r>
+              <a:rPr lang="en-US" sz="1200" dirty="0">
+                <a:solidFill>
+                  <a:srgbClr val="E6EDF3"/>
+                </a:solidFill>
+                <a:latin typeface="Calibri" pitchFamily="34" charset="0"/>
+                <a:ea typeface="Calibri" pitchFamily="34" charset="-122"/>
+                <a:cs typeface="Calibri" pitchFamily="34" charset="-120"/>
+              </a:rPr>
+              <a:t>A new service is added at the top, already open</a:t>
+            </a:r>
+            <a:endParaRPr lang="en-US" sz="1200" dirty="0"/>
+          </a:p>
+          <a:p>
+            <a:pPr marL="342900" indent="-342900">
+              <a:lnSpc>
+                <a:spcPts val="1600"/>
+              </a:lnSpc>
+              <a:spcAft>
+                <a:spcPts val="900"/>
+              </a:spcAft>
+              <a:buSzPct val="100000"/>
+              <a:buChar char="●"/>
+            </a:pPr>
+            <a:r>
+              <a:rPr lang="en-US" sz="1200" dirty="0">
+                <a:solidFill>
+                  <a:srgbClr val="E6EDF3"/>
+                </a:solidFill>
+                <a:latin typeface="Calibri" pitchFamily="34" charset="0"/>
+                <a:ea typeface="Calibri" pitchFamily="34" charset="-122"/>
+                <a:cs typeface="Calibri" pitchFamily="34" charset="-120"/>
+              </a:rPr>
+              <a:t>Resources belong to a scope step, so applying the service files them against the right task</a:t>
+            </a:r>
+            <a:endParaRPr lang="en-US" sz="1200" dirty="0"/>
+          </a:p>
+          <a:p>
+            <a:pPr marL="342900" indent="-342900">
+              <a:lnSpc>
+                <a:spcPts val="1600"/>
+              </a:lnSpc>
+              <a:spcAft>
+                <a:spcPts val="900"/>
+              </a:spcAft>
+              <a:buSzPct val="100000"/>
+              <a:buChar char="●"/>
+            </a:pPr>
+            <a:r>
+              <a:rPr lang="en-US" sz="1200" dirty="0">
+                <a:solidFill>
+                  <a:srgbClr val="E6EDF3"/>
+                </a:solidFill>
+                <a:latin typeface="Calibri" pitchFamily="34" charset="0"/>
+                <a:ea typeface="Calibri" pitchFamily="34" charset="-122"/>
+                <a:cs typeface="Calibri" pitchFamily="34" charset="-120"/>
+              </a:rPr>
+              <a:t>Leave a manpower row's Days blank if that role is on site for the whole project; enter a number if it is only needed for its step</a:t>
+            </a:r>
+            <a:endParaRPr lang="en-US" sz="1200" dirty="0"/>
+          </a:p>
+        </p:txBody>
+      </p:sp>
+      <p:sp>
+        <p:nvSpPr>
+          <p:cNvPr id="8" name="Shape 6"/>
+          <p:cNvSpPr/>
+          <p:nvPr/>
+        </p:nvSpPr>
+        <p:spPr>
+          <a:xfrm>
+            <a:off x="6400800" y="1911096"/>
+            <a:ext cx="5221224" cy="3566160"/>
+          </a:xfrm>
+          <a:prstGeom prst="roundRect">
+            <a:avLst>
+              <a:gd name="adj" fmla="val 2051"/>
+            </a:avLst>
+          </a:prstGeom>
+          <a:solidFill>
+            <a:srgbClr val="1C2128"/>
+          </a:solidFill>
+          <a:ln w="12700">
+            <a:solidFill>
+              <a:srgbClr val="30363D"/>
+            </a:solidFill>
+            <a:prstDash val="solid"/>
+          </a:ln>
+          <a:effectLst>
+            <a:outerShdw sx="100000" sy="100000" kx="0" ky="0" algn="bl" rotWithShape="0" blurRad="152400" dist="38100" dir="5400000">
+              <a:srgbClr val="000000">
+                <a:alpha val="45000"/>
+              </a:srgbClr>
+            </a:outerShdw>
+          </a:effectLst>
+        </p:spPr>
+      </p:sp>
+      <p:sp>
+        <p:nvSpPr>
+          <p:cNvPr id="9" name="Text 7"/>
+          <p:cNvSpPr/>
+          <p:nvPr/>
+        </p:nvSpPr>
+        <p:spPr>
+          <a:xfrm>
+            <a:off x="6675120" y="2121408"/>
+            <a:ext cx="4663440" cy="329184"/>
+          </a:xfrm>
+          <a:prstGeom prst="rect">
+            <a:avLst/>
+          </a:prstGeom>
+          <a:noFill/>
+          <a:ln/>
+        </p:spPr>
+        <p:txBody>
+          <a:bodyPr wrap="square" lIns="0" tIns="0" rIns="0" bIns="0" rtlCol="0" anchor="ctr"/>
+          <a:lstStyle/>
+          <a:p>
+            <a:pPr indent="0" marL="0">
+              <a:buNone/>
+            </a:pPr>
+            <a:r>
+              <a:rPr lang="en-US" sz="1700" b="1" dirty="0">
+                <a:solidFill>
+                  <a:srgbClr val="F0A429"/>
+                </a:solidFill>
+                <a:latin typeface="Arial" pitchFamily="34" charset="0"/>
+                <a:ea typeface="Arial" pitchFamily="34" charset="-122"/>
+                <a:cs typeface="Arial" pitchFamily="34" charset="-120"/>
+              </a:rPr>
+              <a:t>Masterlist</a:t>
+            </a:r>
+            <a:endParaRPr lang="en-US" sz="1700" dirty="0"/>
+          </a:p>
+        </p:txBody>
+      </p:sp>
+      <p:sp>
+        <p:nvSpPr>
+          <p:cNvPr id="10" name="Text 8"/>
+          <p:cNvSpPr/>
+          <p:nvPr/>
+        </p:nvSpPr>
+        <p:spPr>
+          <a:xfrm>
+            <a:off x="6675120" y="2578608"/>
+            <a:ext cx="4709160" cy="2651760"/>
+          </a:xfrm>
+          <a:prstGeom prst="rect">
+            <a:avLst/>
+          </a:prstGeom>
+          <a:noFill/>
+          <a:ln/>
+        </p:spPr>
+        <p:txBody>
+          <a:bodyPr wrap="square" lIns="0" tIns="0" rIns="0" bIns="0" rtlCol="0" anchor="t"/>
+          <a:lstStyle/>
+          <a:p>
+            <a:pPr marL="342900" indent="-342900">
+              <a:lnSpc>
+                <a:spcPts val="1600"/>
+              </a:lnSpc>
+              <a:spcAft>
+                <a:spcPts val="900"/>
+              </a:spcAft>
+              <a:buSzPct val="100000"/>
+              <a:buChar char="●"/>
+            </a:pPr>
+            <a:r>
+              <a:rPr lang="en-US" sz="1200" dirty="0">
+                <a:solidFill>
+                  <a:srgbClr val="E6EDF3"/>
+                </a:solidFill>
+                <a:latin typeface="Calibri" pitchFamily="34" charset="0"/>
+                <a:ea typeface="Calibri" pitchFamily="34" charset="-122"/>
+                <a:cs typeface="Calibri" pitchFamily="34" charset="-120"/>
+              </a:rPr>
+              <a:t>The single source of rates for manpower, tools, materials and PPE</a:t>
+            </a:r>
+            <a:endParaRPr lang="en-US" sz="1200" dirty="0"/>
+          </a:p>
+          <a:p>
+            <a:pPr marL="342900" indent="-342900">
+              <a:lnSpc>
+                <a:spcPts val="1600"/>
+              </a:lnSpc>
+              <a:spcAft>
+                <a:spcPts val="900"/>
+              </a:spcAft>
+              <a:buSzPct val="100000"/>
+              <a:buChar char="●"/>
+            </a:pPr>
+            <a:r>
+              <a:rPr lang="en-US" sz="1200" dirty="0">
+                <a:solidFill>
+                  <a:srgbClr val="E6EDF3"/>
+                </a:solidFill>
+                <a:latin typeface="Calibri" pitchFamily="34" charset="0"/>
+                <a:ea typeface="Calibri" pitchFamily="34" charset="-122"/>
+                <a:cs typeface="Calibri" pitchFamily="34" charset="-120"/>
+              </a:rPr>
+              <a:t>Every rate you pick in a CE comes from here</a:t>
+            </a:r>
+            <a:endParaRPr lang="en-US" sz="1200" dirty="0"/>
+          </a:p>
+          <a:p>
+            <a:pPr marL="342900" indent="-342900">
+              <a:lnSpc>
+                <a:spcPts val="1600"/>
+              </a:lnSpc>
+              <a:spcAft>
+                <a:spcPts val="900"/>
+              </a:spcAft>
+              <a:buSzPct val="100000"/>
+              <a:buChar char="●"/>
+            </a:pPr>
+            <a:r>
+              <a:rPr lang="en-US" sz="1200" dirty="0">
+                <a:solidFill>
+                  <a:srgbClr val="E6EDF3"/>
+                </a:solidFill>
+                <a:latin typeface="Calibri" pitchFamily="34" charset="0"/>
+                <a:ea typeface="Calibri" pitchFamily="34" charset="-122"/>
+                <a:cs typeface="Calibri" pitchFamily="34" charset="-120"/>
+              </a:rPr>
+              <a:t>Update a rate once and use ↺ Sync Rates on an older CE to bring it up to date</a:t>
+            </a:r>
+            <a:endParaRPr lang="en-US" sz="1200" dirty="0"/>
+          </a:p>
+          <a:p>
+            <a:pPr marL="342900" indent="-342900">
+              <a:lnSpc>
+                <a:spcPts val="1600"/>
+              </a:lnSpc>
+              <a:spcAft>
+                <a:spcPts val="900"/>
+              </a:spcAft>
+              <a:buSzPct val="100000"/>
+              <a:buChar char="●"/>
+            </a:pPr>
+            <a:r>
+              <a:rPr lang="en-US" sz="1200" dirty="0">
+                <a:solidFill>
+                  <a:srgbClr val="E6EDF3"/>
+                </a:solidFill>
+                <a:latin typeface="Calibri" pitchFamily="34" charset="0"/>
+                <a:ea typeface="Calibri" pitchFamily="34" charset="-122"/>
+                <a:cs typeface="Calibri" pitchFamily="34" charset="-120"/>
+              </a:rPr>
+              <a:t>Changing a rate does not alter CEs already saved</a:t>
+            </a:r>
+            <a:endParaRPr lang="en-US" sz="1200" dirty="0"/>
+          </a:p>
+        </p:txBody>
+      </p:sp>
+      <p:sp>
+        <p:nvSpPr>
+          <p:cNvPr id="11" name="Text 9"/>
+          <p:cNvSpPr/>
+          <p:nvPr/>
+        </p:nvSpPr>
+        <p:spPr>
+          <a:xfrm>
+            <a:off x="566928" y="6437376"/>
+            <a:ext cx="5486400" cy="237744"/>
+          </a:xfrm>
+          <a:prstGeom prst="rect">
+            <a:avLst/>
+          </a:prstGeom>
+          <a:noFill/>
+          <a:ln/>
+        </p:spPr>
+        <p:txBody>
+          <a:bodyPr wrap="square" lIns="0" tIns="0" rIns="0" bIns="0" rtlCol="0" anchor="ctr"/>
+          <a:lstStyle/>
+          <a:p>
+            <a:pPr indent="0" marL="0">
+              <a:buNone/>
+            </a:pPr>
+            <a:r>
+              <a:rPr lang="en-US" sz="900" dirty="0">
+                <a:solidFill>
+                  <a:srgbClr val="6E7681"/>
+                </a:solidFill>
+                <a:latin typeface="Calibri" pitchFamily="34" charset="0"/>
+                <a:ea typeface="Calibri" pitchFamily="34" charset="-122"/>
+                <a:cs typeface="Calibri" pitchFamily="34" charset="-120"/>
+              </a:rPr>
+              <a:t>SHIC Cost Estimator — End-User Manual</a:t>
+            </a:r>
+            <a:endParaRPr lang="en-US" sz="900" dirty="0"/>
+          </a:p>
+        </p:txBody>
+      </p:sp>
+      <p:sp>
+        <p:nvSpPr>
+          <p:cNvPr id="12" name="Text 10"/>
+          <p:cNvSpPr/>
+          <p:nvPr/>
+        </p:nvSpPr>
+        <p:spPr>
+          <a:xfrm>
+            <a:off x="10981944" y="6437376"/>
+            <a:ext cx="640080" cy="237744"/>
+          </a:xfrm>
+          <a:prstGeom prst="rect">
+            <a:avLst/>
+          </a:prstGeom>
+          <a:noFill/>
+          <a:ln/>
+        </p:spPr>
+        <p:txBody>
+          <a:bodyPr wrap="square" lIns="0" tIns="0" rIns="0" bIns="0" rtlCol="0" anchor="ctr"/>
+          <a:lstStyle/>
+          <a:p>
+            <a:pPr algn="r" indent="0" marL="0">
+              <a:buNone/>
+            </a:pPr>
+            <a:r>
+              <a:rPr lang="en-US" sz="900" dirty="0">
+                <a:solidFill>
+                  <a:srgbClr val="6E7681"/>
+                </a:solidFill>
+                <a:latin typeface="Calibri" pitchFamily="34" charset="0"/>
+                <a:ea typeface="Calibri" pitchFamily="34" charset="-122"/>
+                <a:cs typeface="Calibri" pitchFamily="34" charset="-120"/>
+              </a:rPr>
+              <a:t>20</a:t>
+            </a:r>
+            <a:endParaRPr lang="en-US" sz="900" dirty="0"/>
+          </a:p>
+        </p:txBody>
+      </p:sp>
+    </p:spTree>
+  </p:cSld>
+  <p:clrMapOvr>
+    <a:masterClrMapping/>
+  </p:clrMapOvr>
+</p:sld>
+</file>
+
+<file path=ppt/slides/slide21.xml><?xml version="1.0" encoding="utf-8"?>
+<p:sld xmlns:a="http://schemas.openxmlformats.org/drawingml/2006/main" xmlns:r="http://schemas.openxmlformats.org/officeDocument/2006/relationships" xmlns:p="http://schemas.openxmlformats.org/presentationml/2006/main">
+  <p:cSld name="Slide 21">
     <p:bg>
       <p:bgPr>
         <a:solidFill>
@@ -15765,7 +17621,7 @@
           <a:ln/>
         </p:spPr>
         <p:txBody>
-          <a:bodyPr wrap="square" lIns="0" tIns="0" rIns="0" bIns="0" rtlCol="0" anchor="ctr"/>
+          <a:bodyPr wrap="square" lIns="0" tIns="0" rIns="0" bIns="0" rtlCol="0" anchor="t"/>
           <a:lstStyle/>
           <a:p>
             <a:pPr marL="342900" indent="-342900">
@@ -15860,6 +17716,30 @@
                 <a:cs typeface="Calibri" pitchFamily="34" charset="-120"/>
               </a:rPr>
               <a:t>A CE Number can only be used once</a:t>
+            </a:r>
+            <a:endParaRPr lang="en-US" sz="1150" dirty="0"/>
+          </a:p>
+          <a:p>
+            <a:pPr marL="342900" indent="-342900">
+              <a:lnSpc>
+                <a:spcPts val="1450"/>
+              </a:lnSpc>
+              <a:spcAft>
+                <a:spcPts val="500"/>
+              </a:spcAft>
+              <a:buSzPct val="100000"/>
+              <a:buChar char="●"/>
+            </a:pPr>
+            <a:r>
+              <a:rPr lang="en-US" sz="1150" dirty="0">
+                <a:solidFill>
+                  <a:srgbClr val="E6EDF3"/>
+                </a:solidFill>
+                <a:latin typeface="Calibri" pitchFamily="34" charset="0"/>
+                <a:ea typeface="Calibri" pitchFamily="34" charset="-122"/>
+                <a:cs typeface="Calibri" pitchFamily="34" charset="-120"/>
+              </a:rPr>
+              <a:t>Consolidate the crew before you generate</a:t>
             </a:r>
             <a:endParaRPr lang="en-US" sz="1150" dirty="0"/>
           </a:p>
@@ -16479,7 +18359,7 @@
                 <a:ea typeface="Calibri" pitchFamily="34" charset="-122"/>
                 <a:cs typeface="Calibri" pitchFamily="34" charset="-120"/>
               </a:rPr>
-              <a:t>20</a:t>
+              <a:t>21</a:t>
             </a:r>
             <a:endParaRPr lang="en-US" sz="900" dirty="0"/>
           </a:p>
@@ -19442,7 +21322,7 @@
           <a:ln/>
         </p:spPr>
         <p:txBody>
-          <a:bodyPr wrap="square" lIns="0" tIns="0" rIns="0" bIns="0" rtlCol="0" anchor="ctr"/>
+          <a:bodyPr wrap="square" lIns="0" tIns="0" rIns="0" bIns="0" rtlCol="0" anchor="t"/>
           <a:lstStyle/>
           <a:p>
             <a:pPr marL="342900" indent="-342900">
@@ -25089,7 +26969,7 @@
                 <a:ea typeface="Arial" pitchFamily="34" charset="-122"/>
                 <a:cs typeface="Arial" pitchFamily="34" charset="-120"/>
               </a:rPr>
-              <a:t>Breakdown note</a:t>
+              <a:t>Shared crew</a:t>
             </a:r>
             <a:endParaRPr lang="en-US" sz="1350" dirty="0"/>
           </a:p>
@@ -25131,7 +27011,7 @@
                 <a:ea typeface="Calibri" pitchFamily="34" charset="-122"/>
                 <a:cs typeface="Calibri" pitchFamily="34" charset="-120"/>
               </a:rPr>
-              <a:t>Explain how a task was costed. It prints with the CE notes, labelled "Scope 1.1".</a:t>
+              <a:t>After consolidating, one row serves several tasks, listed under each with its cost split in proportion.</a:t>
             </a:r>
             <a:endParaRPr lang="en-US" sz="1100" dirty="0"/>
           </a:p>
@@ -26894,7 +28774,7 @@
                 <a:ea typeface="Arial" pitchFamily="34" charset="-122"/>
                 <a:cs typeface="Arial" pitchFamily="34" charset="-120"/>
               </a:rPr>
-              <a:t>Adding a row</a:t>
+              <a:t>The Scope Task column</a:t>
             </a:r>
             <a:endParaRPr lang="en-US" sz="1400" dirty="0"/>
           </a:p>
@@ -26936,7 +28816,7 @@
                 <a:ea typeface="Calibri" pitchFamily="34" charset="-122"/>
                 <a:cs typeface="Calibri" pitchFamily="34" charset="-120"/>
               </a:rPr>
-              <a:t>+ Masterlist picks a role and brings its rate and per diem with it — always prefer that to typing. + Blank adds an empty row. Row Total here is pay plus overtime; benefits are added into the grand total on the Summary tab.</a:t>
+              <a:t>Every row shows which scope task it belongs to, so two rows for one role are explained rather than mysterious — they are different crews on different tasks. Change a row’s task here or in SOW Breakdown. Row Total is pay plus overtime; benefits land in the grand total.</a:t>
             </a:r>
             <a:endParaRPr lang="en-US" sz="1150" dirty="0"/>
           </a:p>

</xml_diff>